<commit_message>
Purchase order paper in the owner's layout: details two to a line, supplier and delivery blocks side by side, signature note
Co-Authored-By: Claude Opus 5.5 <noreply@anthropic.com>
Claude-Session: https://claude.ai/code/session_017S7WKxPcaD1eFJsYc4Pw2Y
</commit_message>
<xml_diff>
--- a/docs/mockups/purchase-order-layout.pptx
+++ b/docs/mockups/purchase-order-layout.pptx
@@ -4,14 +4,14 @@
   <p:sldMasterIdLst>
     <p:sldMasterId id="2147483648" r:id="rId1"/>
   </p:sldMasterIdLst>
+  <p:notesMasterIdLst>
+    <p:notesMasterId r:id="rId3"/>
+  </p:notesMasterIdLst>
   <p:sldIdLst>
     <p:sldId id="256" r:id="rId2"/>
   </p:sldIdLst>
-  <p:notesMasterIdLst>
-    <p:notesMasterId r:id="rId3"/>
-  </p:notesMasterIdLst>
-  <p:sldSz cx="7562088" cy="10689336"/>
-  <p:notesSz cx="10689336" cy="7562088"/>
+  <p:sldSz cx="7562850" cy="10688638"/>
+  <p:notesSz cx="10688638" cy="7562850"/>
   <p:defaultTextStyle>
     <a:lvl1pPr marL="0" algn="l" defTabSz="914400" rtl="0" eaLnBrk="1" latinLnBrk="0" hangingPunct="1">
       <a:defRPr sz="1800" kern="1200">
@@ -104,6 +104,11 @@
       </a:defRPr>
     </a:lvl9pPr>
   </p:defaultTextStyle>
+  <p:extLst>
+    <p:ext uri="{EFAFB233-063F-42B5-8137-9DF3F51BA10A}">
+      <p15:sldGuideLst xmlns:p15="http://schemas.microsoft.com/office/powerpoint/2012/main"/>
+    </p:ext>
+  </p:extLst>
 </p:presentation>
 </file>
 
@@ -129,234 +134,10 @@
           <a:chExt cx="0" cy="0"/>
         </a:xfrm>
       </p:grpSpPr>
-      <p:sp>
-        <p:nvSpPr>
-          <p:cNvPr id="2" name="Header Placeholder 1"/>
-          <p:cNvSpPr>
-            <a:spLocks noGrp="1"/>
-          </p:cNvSpPr>
-          <p:nvPr>
-            <p:ph type="hdr" sz="quarter"/>
-          </p:nvPr>
-        </p:nvSpPr>
-        <p:spPr>
-          <a:xfrm>
-            <a:off x="0" y="0"/>
-            <a:ext cx="2971800" cy="458788"/>
-          </a:xfrm>
-          <a:prstGeom prst="rect">
-            <a:avLst/>
-          </a:prstGeom>
-        </p:spPr>
-        <p:txBody>
-          <a:bodyPr vert="horz" lIns="91440" tIns="45720" rIns="91440" bIns="45720" rtlCol="0"/>
-          <a:lstStyle>
-            <a:lvl1pPr algn="l">
-              <a:defRPr sz="1200"/>
-            </a:lvl1pPr>
-          </a:lstStyle>
-          <a:p>
-            <a:endParaRPr lang="en-US"/>
-          </a:p>
-        </p:txBody>
-      </p:sp>
-      <p:sp>
-        <p:nvSpPr>
-          <p:cNvPr id="3" name="Date Placeholder 2"/>
-          <p:cNvSpPr>
-            <a:spLocks noGrp="1"/>
-          </p:cNvSpPr>
-          <p:nvPr>
-            <p:ph type="dt" idx="1"/>
-          </p:nvPr>
-        </p:nvSpPr>
-        <p:spPr>
-          <a:xfrm>
-            <a:off x="3884613" y="0"/>
-            <a:ext cx="2971800" cy="458788"/>
-          </a:xfrm>
-          <a:prstGeom prst="rect">
-            <a:avLst/>
-          </a:prstGeom>
-        </p:spPr>
-        <p:txBody>
-          <a:bodyPr vert="horz" lIns="91440" tIns="45720" rIns="91440" bIns="45720" rtlCol="0"/>
-          <a:lstStyle>
-            <a:lvl1pPr algn="r">
-              <a:defRPr sz="1200"/>
-            </a:lvl1pPr>
-          </a:lstStyle>
-          <a:p>
-            <a:fld id="{5282F153-3F37-0F45-9E97-73ACFA13230C}" type="datetimeFigureOut">
-              <a:rPr lang="en-US"/>
-              <a:t>7/23/19</a:t>
-            </a:fld>
-            <a:endParaRPr lang="en-US"/>
-          </a:p>
-        </p:txBody>
-      </p:sp>
-      <p:sp>
-        <p:nvSpPr>
-          <p:cNvPr id="4" name="Slide Image Placeholder 3"/>
-          <p:cNvSpPr>
-            <a:spLocks noGrp="1" noRot="1" noChangeAspect="1"/>
-          </p:cNvSpPr>
-          <p:nvPr>
-            <p:ph type="sldImg" idx="2"/>
-          </p:nvPr>
-        </p:nvSpPr>
-        <p:spPr>
-          <a:xfrm>
-            <a:off x="685800" y="1143000"/>
-            <a:ext cx="5486400" cy="3086100"/>
-          </a:xfrm>
-          <a:prstGeom prst="rect">
-            <a:avLst/>
-          </a:prstGeom>
-          <a:noFill/>
-          <a:ln w="12700">
-            <a:solidFill>
-              <a:prstClr val="black"/>
-            </a:solidFill>
-          </a:ln>
-        </p:spPr>
-        <p:txBody>
-          <a:bodyPr vert="horz" lIns="91440" tIns="45720" rIns="91440" bIns="45720" rtlCol="0" anchor="ctr"/>
-          <a:lstStyle/>
-          <a:p>
-            <a:endParaRPr lang="en-US"/>
-          </a:p>
-        </p:txBody>
-      </p:sp>
-      <p:sp>
-        <p:nvSpPr>
-          <p:cNvPr id="5" name="Notes Placeholder 4"/>
-          <p:cNvSpPr>
-            <a:spLocks noGrp="1"/>
-          </p:cNvSpPr>
-          <p:nvPr>
-            <p:ph type="body" sz="quarter" idx="3"/>
-          </p:nvPr>
-        </p:nvSpPr>
-        <p:spPr>
-          <a:xfrm>
-            <a:off x="685800" y="4400550"/>
-            <a:ext cx="5486400" cy="3600450"/>
-          </a:xfrm>
-          <a:prstGeom prst="rect">
-            <a:avLst/>
-          </a:prstGeom>
-        </p:spPr>
-        <p:txBody>
-          <a:bodyPr vert="horz" lIns="91440" tIns="45720" rIns="91440" bIns="45720" rtlCol="0"/>
-          <a:lstStyle/>
-          <a:p>
-            <a:pPr lvl="0"/>
-            <a:r>
-              <a:rPr lang="en-US"/>
-              <a:t>Click to edit Master text styles</a:t>
-            </a:r>
-          </a:p>
-          <a:p>
-            <a:pPr lvl="1"/>
-            <a:r>
-              <a:rPr lang="en-US"/>
-              <a:t>Second level</a:t>
-            </a:r>
-          </a:p>
-          <a:p>
-            <a:pPr lvl="2"/>
-            <a:r>
-              <a:rPr lang="en-US"/>
-              <a:t>Third level</a:t>
-            </a:r>
-          </a:p>
-          <a:p>
-            <a:pPr lvl="3"/>
-            <a:r>
-              <a:rPr lang="en-US"/>
-              <a:t>Fourth level</a:t>
-            </a:r>
-          </a:p>
-          <a:p>
-            <a:pPr lvl="4"/>
-            <a:r>
-              <a:rPr lang="en-US"/>
-              <a:t>Fifth level</a:t>
-            </a:r>
-          </a:p>
-        </p:txBody>
-      </p:sp>
-      <p:sp>
-        <p:nvSpPr>
-          <p:cNvPr id="6" name="Footer Placeholder 5"/>
-          <p:cNvSpPr>
-            <a:spLocks noGrp="1"/>
-          </p:cNvSpPr>
-          <p:nvPr>
-            <p:ph type="ftr" sz="quarter" idx="4"/>
-          </p:nvPr>
-        </p:nvSpPr>
-        <p:spPr>
-          <a:xfrm>
-            <a:off x="0" y="8685213"/>
-            <a:ext cx="2971800" cy="458787"/>
-          </a:xfrm>
-          <a:prstGeom prst="rect">
-            <a:avLst/>
-          </a:prstGeom>
-        </p:spPr>
-        <p:txBody>
-          <a:bodyPr vert="horz" lIns="91440" tIns="45720" rIns="91440" bIns="45720" rtlCol="0" anchor="b"/>
-          <a:lstStyle>
-            <a:lvl1pPr algn="l">
-              <a:defRPr sz="1200"/>
-            </a:lvl1pPr>
-          </a:lstStyle>
-          <a:p>
-            <a:endParaRPr lang="en-US"/>
-          </a:p>
-        </p:txBody>
-      </p:sp>
-      <p:sp>
-        <p:nvSpPr>
-          <p:cNvPr id="7" name="Slide Number Placeholder 6"/>
-          <p:cNvSpPr>
-            <a:spLocks noGrp="1"/>
-          </p:cNvSpPr>
-          <p:nvPr>
-            <p:ph type="sldNum" sz="quarter" idx="5"/>
-          </p:nvPr>
-        </p:nvSpPr>
-        <p:spPr>
-          <a:xfrm>
-            <a:off x="3884613" y="8685213"/>
-            <a:ext cx="2971800" cy="458787"/>
-          </a:xfrm>
-          <a:prstGeom prst="rect">
-            <a:avLst/>
-          </a:prstGeom>
-        </p:spPr>
-        <p:txBody>
-          <a:bodyPr vert="horz" lIns="91440" tIns="45720" rIns="91440" bIns="45720" rtlCol="0" anchor="b"/>
-          <a:lstStyle>
-            <a:lvl1pPr algn="r">
-              <a:defRPr sz="1200"/>
-            </a:lvl1pPr>
-          </a:lstStyle>
-          <a:p>
-            <a:fld id="{CE5E9CC1-C706-0F49-92D6-E571CC5EEA8F}" type="slidenum">
-              <a:rPr lang="en-US"/>
-              <a:t>‹#›</a:t>
-            </a:fld>
-            <a:endParaRPr lang="en-US"/>
-          </a:p>
-        </p:txBody>
-      </p:sp>
     </p:spTree>
     <p:extLst>
       <p:ext uri="{BB962C8B-B14F-4D97-AF65-F5344CB8AC3E}">
-        <p14:creationId xmlns:p14="http://schemas.microsoft.com/office/powerpoint/2010/main" val="1024086991"/>
+        <p14:creationId xmlns:p14="http://schemas.microsoft.com/office/powerpoint/2010/main" val="1818138776"/>
       </p:ext>
     </p:extLst>
   </p:cSld>
@@ -504,7 +285,6 @@
               <a:rPr lang="en-US" dirty="0"/>
               <a:t>Each block is its own box (named in the Selection Pane). Move or resize them to show where you want each part of the Purchase Order printout.</a:t>
             </a:r>
-            <a:endParaRPr lang="en-US" dirty="0"/>
           </a:p>
         </p:txBody>
       </p:sp>
@@ -577,6 +357,11 @@
 <file path=ppt/slideMasters/slideMaster1.xml><?xml version="1.0" encoding="utf-8"?>
 <p:sldMaster xmlns:a="http://schemas.openxmlformats.org/drawingml/2006/main" xmlns:r="http://schemas.openxmlformats.org/officeDocument/2006/relationships" xmlns:p="http://schemas.openxmlformats.org/presentationml/2006/main">
   <p:cSld>
+    <p:bg>
+      <p:bgRef idx="1001">
+        <a:schemeClr val="bg1"/>
+      </p:bgRef>
+    </p:bg>
     <p:spTree>
       <p:nvGrpSpPr>
         <p:cNvPr id="1" name=""/>
@@ -912,7 +697,7 @@
           <a:bodyPr wrap="square" lIns="0" tIns="0" rIns="0" bIns="0" rtlCol="0" anchor="t"/>
           <a:lstStyle/>
           <a:p>
-            <a:pPr algn="ctr" indent="0" marL="0">
+            <a:pPr marL="0" indent="0" algn="ctr">
               <a:buNone/>
             </a:pPr>
             <a:r>
@@ -951,7 +736,7 @@
           <a:bodyPr wrap="square" lIns="0" tIns="0" rIns="0" bIns="0" rtlCol="0" anchor="t"/>
           <a:lstStyle/>
           <a:p>
-            <a:pPr indent="0" marL="0">
+            <a:pPr marL="0" indent="0">
               <a:buNone/>
             </a:pPr>
             <a:r>
@@ -990,7 +775,7 @@
           <a:bodyPr wrap="square" lIns="0" tIns="0" rIns="0" bIns="0" rtlCol="0" anchor="t"/>
           <a:lstStyle/>
           <a:p>
-            <a:pPr indent="0" marL="0">
+            <a:pPr marL="0" indent="0">
               <a:lnSpc>
                 <a:spcPct val="125000"/>
               </a:lnSpc>
@@ -1010,7 +795,7 @@
             <a:endParaRPr lang="en-US" sz="750" dirty="0"/>
           </a:p>
           <a:p>
-            <a:pPr indent="0" marL="0">
+            <a:pPr marL="0" indent="0">
               <a:lnSpc>
                 <a:spcPct val="125000"/>
               </a:lnSpc>
@@ -1030,7 +815,7 @@
             <a:endParaRPr lang="en-US" sz="750" dirty="0"/>
           </a:p>
           <a:p>
-            <a:pPr indent="0" marL="0">
+            <a:pPr marL="0" indent="0">
               <a:lnSpc>
                 <a:spcPct val="125000"/>
               </a:lnSpc>
@@ -1050,7 +835,7 @@
             <a:endParaRPr lang="en-US" sz="750" dirty="0"/>
           </a:p>
           <a:p>
-            <a:pPr indent="0" marL="0">
+            <a:pPr marL="0" indent="0">
               <a:lnSpc>
                 <a:spcPct val="125000"/>
               </a:lnSpc>
@@ -1092,11 +877,11 @@
           <a:bodyPr wrap="square" lIns="0" tIns="0" rIns="0" bIns="0" rtlCol="0" anchor="t"/>
           <a:lstStyle/>
           <a:p>
-            <a:pPr algn="r" indent="0" marL="0">
+            <a:pPr marL="0" indent="0" algn="r">
               <a:buNone/>
             </a:pPr>
             <a:r>
-              <a:rPr lang="en-US" sz="2400" dirty="0">
+              <a:rPr lang="en-US" sz="2400" b="1" dirty="0">
                 <a:solidFill>
                   <a:srgbClr val="5B2A8C"/>
                 </a:solidFill>
@@ -1106,14 +891,14 @@
               </a:rPr>
               <a:t>PURCHASE</a:t>
             </a:r>
-            <a:endParaRPr lang="en-US" sz="2400" dirty="0"/>
+            <a:endParaRPr lang="en-US" sz="2400" b="1" dirty="0"/>
           </a:p>
           <a:p>
-            <a:pPr algn="r" indent="0" marL="0">
+            <a:pPr marL="0" indent="0" algn="r">
               <a:buNone/>
             </a:pPr>
             <a:r>
-              <a:rPr lang="en-US" sz="2400" dirty="0">
+              <a:rPr lang="en-US" sz="2400" b="1" dirty="0">
                 <a:solidFill>
                   <a:srgbClr val="5B2A8C"/>
                 </a:solidFill>
@@ -1123,7 +908,7 @@
               </a:rPr>
               <a:t>ORDER</a:t>
             </a:r>
-            <a:endParaRPr lang="en-US" sz="2400" dirty="0"/>
+            <a:endParaRPr lang="en-US" sz="2400" b="1" dirty="0"/>
           </a:p>
         </p:txBody>
       </p:sp>
@@ -1148,7 +933,7 @@
           <a:bodyPr wrap="square" lIns="0" tIns="0" rIns="0" bIns="0" rtlCol="0" anchor="t"/>
           <a:lstStyle/>
           <a:p>
-            <a:pPr algn="r" indent="0" marL="0">
+            <a:pPr marL="0" indent="0" algn="r">
               <a:buNone/>
             </a:pPr>
             <a:r>
@@ -1187,7 +972,7 @@
           <a:bodyPr wrap="square" lIns="0" tIns="0" rIns="0" bIns="0" rtlCol="0" anchor="t"/>
           <a:lstStyle/>
           <a:p>
-            <a:pPr algn="r" indent="0" marL="0">
+            <a:pPr marL="0" indent="0" algn="r">
               <a:buNone/>
             </a:pPr>
             <a:r>
@@ -1199,7 +984,7 @@
                 <a:ea typeface="Arial" pitchFamily="34" charset="-122"/>
                 <a:cs typeface="Arial" pitchFamily="34" charset="-120"/>
               </a:rPr>
-              <a:t>P.O. Date: October 14, 2026</a:t>
+              <a:t>Date: October 14, 2026</a:t>
             </a:r>
             <a:endParaRPr lang="en-US" sz="950" dirty="0"/>
           </a:p>
@@ -1213,7 +998,7 @@
         </p:nvSpPr>
         <p:spPr>
           <a:xfrm>
-            <a:off x="457200" y="1803862"/>
+            <a:off x="457200" y="1570182"/>
             <a:ext cx="6650182" cy="0"/>
           </a:xfrm>
           <a:prstGeom prst="line">
@@ -1236,7 +1021,7 @@
         </p:nvSpPr>
         <p:spPr>
           <a:xfrm>
-            <a:off x="457200" y="2053244"/>
+            <a:off x="457200" y="1819564"/>
             <a:ext cx="2493818" cy="149629"/>
           </a:xfrm>
           <a:prstGeom prst="rect">
@@ -1249,7 +1034,7 @@
           <a:bodyPr wrap="square" lIns="0" tIns="0" rIns="0" bIns="0" rtlCol="0" anchor="t"/>
           <a:lstStyle/>
           <a:p>
-            <a:pPr indent="0" marL="0">
+            <a:pPr marL="0" indent="0">
               <a:buNone/>
             </a:pPr>
             <a:r>
@@ -1275,8 +1060,8 @@
         </p:nvSpPr>
         <p:spPr>
           <a:xfrm>
-            <a:off x="457200" y="2335876"/>
-            <a:ext cx="3325091" cy="382385"/>
+            <a:off x="457200" y="2102197"/>
+            <a:ext cx="3325091" cy="224444"/>
           </a:xfrm>
           <a:prstGeom prst="rect">
             <a:avLst/>
@@ -1288,7 +1073,7 @@
           <a:bodyPr wrap="square" lIns="0" tIns="0" rIns="0" bIns="0" rtlCol="0" anchor="t"/>
           <a:lstStyle/>
           <a:p>
-            <a:pPr indent="0" marL="0">
+            <a:pPr marL="0" indent="0">
               <a:lnSpc>
                 <a:spcPct val="130000"/>
               </a:lnSpc>
@@ -1307,26 +1092,6 @@
             </a:r>
             <a:endParaRPr lang="en-US" sz="950" dirty="0"/>
           </a:p>
-          <a:p>
-            <a:pPr indent="0" marL="0">
-              <a:lnSpc>
-                <a:spcPct val="130000"/>
-              </a:lnSpc>
-              <a:buNone/>
-            </a:pPr>
-            <a:r>
-              <a:rPr lang="en-US" sz="950" b="1" dirty="0">
-                <a:solidFill>
-                  <a:srgbClr val="222222"/>
-                </a:solidFill>
-                <a:latin typeface="Arial" pitchFamily="34" charset="0"/>
-                <a:ea typeface="Arial" pitchFamily="34" charset="-122"/>
-                <a:cs typeface="Arial" pitchFamily="34" charset="-120"/>
-              </a:rPr>
-              <a:t>Delivery date: October 28, 2026</a:t>
-            </a:r>
-            <a:endParaRPr lang="en-US" sz="950" dirty="0"/>
-          </a:p>
         </p:txBody>
       </p:sp>
       <p:sp>
@@ -1337,7 +1102,7 @@
         </p:nvSpPr>
         <p:spPr>
           <a:xfrm>
-            <a:off x="457200" y="3275215"/>
+            <a:off x="457200" y="2431935"/>
             <a:ext cx="2493818" cy="149629"/>
           </a:xfrm>
           <a:prstGeom prst="rect">
@@ -1350,7 +1115,7 @@
           <a:bodyPr wrap="square" lIns="0" tIns="0" rIns="0" bIns="0" rtlCol="0" anchor="t"/>
           <a:lstStyle/>
           <a:p>
-            <a:pPr indent="0" marL="0">
+            <a:pPr marL="0" indent="0">
               <a:buNone/>
             </a:pPr>
             <a:r>
@@ -1376,8 +1141,8 @@
         </p:nvSpPr>
         <p:spPr>
           <a:xfrm>
-            <a:off x="457200" y="3549535"/>
-            <a:ext cx="3158836" cy="382385"/>
+            <a:off x="457200" y="2655455"/>
+            <a:ext cx="3158836" cy="882072"/>
           </a:xfrm>
           <a:prstGeom prst="rect">
             <a:avLst/>
@@ -1389,10 +1154,7 @@
           <a:bodyPr wrap="square" lIns="0" tIns="0" rIns="0" bIns="0" rtlCol="0" anchor="t"/>
           <a:lstStyle/>
           <a:p>
-            <a:pPr indent="0" marL="0">
-              <a:lnSpc>
-                <a:spcPct val="130000"/>
-              </a:lnSpc>
+            <a:pPr marL="0" indent="0">
               <a:buNone/>
             </a:pPr>
             <a:r>
@@ -1404,17 +1166,74 @@
                 <a:ea typeface="Arial" pitchFamily="34" charset="-122"/>
                 <a:cs typeface="Arial" pitchFamily="34" charset="-120"/>
               </a:rPr>
-              <a:t>Supplier: GAS ION TECHNOLOGY INC.</a:t>
+              <a:t>GAS ION TECHNOLOGY INC.</a:t>
+            </a:r>
+            <a:br>
+              <a:rPr lang="en-US" sz="950" b="1" dirty="0">
+                <a:solidFill>
+                  <a:srgbClr val="222222"/>
+                </a:solidFill>
+                <a:latin typeface="Arial" pitchFamily="34" charset="0"/>
+                <a:ea typeface="Arial" pitchFamily="34" charset="-122"/>
+                <a:cs typeface="Arial" pitchFamily="34" charset="-120"/>
+              </a:rPr>
+            </a:br>
+            <a:r>
+              <a:rPr lang="en-US" sz="950" b="1" dirty="0">
+                <a:solidFill>
+                  <a:srgbClr val="222222"/>
+                </a:solidFill>
+                <a:latin typeface="Arial" pitchFamily="34" charset="0"/>
+                <a:ea typeface="Arial" pitchFamily="34" charset="-122"/>
+                <a:cs typeface="Arial" pitchFamily="34" charset="-120"/>
+              </a:rPr>
+              <a:t>#27 Rajah Soliman Street </a:t>
+            </a:r>
+            <a:br>
+              <a:rPr lang="en-US" sz="950" b="1" dirty="0">
+                <a:solidFill>
+                  <a:srgbClr val="222222"/>
+                </a:solidFill>
+                <a:latin typeface="Arial" pitchFamily="34" charset="0"/>
+                <a:ea typeface="Arial" pitchFamily="34" charset="-122"/>
+                <a:cs typeface="Arial" pitchFamily="34" charset="-120"/>
+              </a:rPr>
+            </a:br>
+            <a:r>
+              <a:rPr lang="en-US" sz="950" b="1" dirty="0">
+                <a:solidFill>
+                  <a:srgbClr val="222222"/>
+                </a:solidFill>
+                <a:latin typeface="Arial" pitchFamily="34" charset="0"/>
+                <a:ea typeface="Arial" pitchFamily="34" charset="-122"/>
+                <a:cs typeface="Arial" pitchFamily="34" charset="-120"/>
+              </a:rPr>
+              <a:t>Barangay Marikina Heights Marikina City</a:t>
+            </a:r>
+            <a:br>
+              <a:rPr lang="en-US" sz="950" b="1" dirty="0">
+                <a:solidFill>
+                  <a:srgbClr val="222222"/>
+                </a:solidFill>
+                <a:latin typeface="Arial" pitchFamily="34" charset="0"/>
+                <a:ea typeface="Arial" pitchFamily="34" charset="-122"/>
+                <a:cs typeface="Arial" pitchFamily="34" charset="-120"/>
+              </a:rPr>
+            </a:br>
+            <a:r>
+              <a:rPr lang="en-US" sz="950" b="1" dirty="0">
+                <a:solidFill>
+                  <a:srgbClr val="222222"/>
+                </a:solidFill>
+                <a:latin typeface="Arial" pitchFamily="34" charset="0"/>
+                <a:ea typeface="Arial" pitchFamily="34" charset="-122"/>
+                <a:cs typeface="Arial" pitchFamily="34" charset="-120"/>
+              </a:rPr>
+              <a:t>0917 555 0101</a:t>
             </a:r>
             <a:endParaRPr lang="en-US" sz="950" dirty="0"/>
           </a:p>
           <a:p>
-            <a:pPr indent="0" marL="0">
-              <a:lnSpc>
-                <a:spcPct val="130000"/>
-              </a:lnSpc>
-              <a:buNone/>
-            </a:pPr>
             <a:r>
               <a:rPr lang="en-US" sz="950" b="1" dirty="0">
                 <a:solidFill>
@@ -1424,7 +1243,28 @@
                 <a:ea typeface="Arial" pitchFamily="34" charset="-122"/>
                 <a:cs typeface="Arial" pitchFamily="34" charset="-120"/>
               </a:rPr>
-              <a:t>Contact person: Rosa Lim, Sales Engineer</a:t>
+              <a:t>Rosa Lim, Sales Engineer</a:t>
+            </a:r>
+            <a:br>
+              <a:rPr lang="en-US" sz="950" b="1" dirty="0">
+                <a:solidFill>
+                  <a:srgbClr val="222222"/>
+                </a:solidFill>
+                <a:latin typeface="Arial" pitchFamily="34" charset="0"/>
+                <a:ea typeface="Arial" pitchFamily="34" charset="-122"/>
+                <a:cs typeface="Arial" pitchFamily="34" charset="-120"/>
+              </a:rPr>
+            </a:br>
+            <a:r>
+              <a:rPr lang="en-US" sz="950" b="1" dirty="0" err="1">
+                <a:solidFill>
+                  <a:srgbClr val="222222"/>
+                </a:solidFill>
+                <a:latin typeface="Arial" pitchFamily="34" charset="0"/>
+                <a:ea typeface="Arial" pitchFamily="34" charset="-122"/>
+                <a:cs typeface="Arial" pitchFamily="34" charset="-120"/>
+              </a:rPr>
+              <a:t>rosa.lim@gasion.example</a:t>
             </a:r>
             <a:endParaRPr lang="en-US" sz="950" dirty="0"/>
           </a:p>
@@ -1432,75 +1272,13 @@
       </p:sp>
       <p:sp>
         <p:nvSpPr>
-          <p:cNvPr id="14" name="Supplier right"/>
-          <p:cNvSpPr txBox="1"/>
-          <p:nvPr/>
-        </p:nvSpPr>
-        <p:spPr>
-          <a:xfrm>
-            <a:off x="3782291" y="3549535"/>
-            <a:ext cx="3325091" cy="548640"/>
-          </a:xfrm>
-          <a:prstGeom prst="rect">
-            <a:avLst/>
-          </a:prstGeom>
-          <a:noFill/>
-          <a:ln/>
-        </p:spPr>
-        <p:txBody>
-          <a:bodyPr wrap="square" lIns="0" tIns="0" rIns="0" bIns="0" rtlCol="0" anchor="t"/>
-          <a:lstStyle/>
-          <a:p>
-            <a:pPr indent="0" marL="0">
-              <a:lnSpc>
-                <a:spcPct val="130000"/>
-              </a:lnSpc>
-              <a:buNone/>
-            </a:pPr>
-            <a:r>
-              <a:rPr lang="en-US" sz="950" b="1" dirty="0">
-                <a:solidFill>
-                  <a:srgbClr val="222222"/>
-                </a:solidFill>
-                <a:latin typeface="Arial" pitchFamily="34" charset="0"/>
-                <a:ea typeface="Arial" pitchFamily="34" charset="-122"/>
-                <a:cs typeface="Arial" pitchFamily="34" charset="-120"/>
-              </a:rPr>
-              <a:t>Address: —</a:t>
-            </a:r>
-            <a:endParaRPr lang="en-US" sz="950" dirty="0"/>
-          </a:p>
-          <a:p>
-            <a:pPr indent="0" marL="0">
-              <a:lnSpc>
-                <a:spcPct val="130000"/>
-              </a:lnSpc>
-              <a:buNone/>
-            </a:pPr>
-            <a:r>
-              <a:rPr lang="en-US" sz="950" b="1" dirty="0">
-                <a:solidFill>
-                  <a:srgbClr val="222222"/>
-                </a:solidFill>
-                <a:latin typeface="Arial" pitchFamily="34" charset="0"/>
-                <a:ea typeface="Arial" pitchFamily="34" charset="-122"/>
-                <a:cs typeface="Arial" pitchFamily="34" charset="-120"/>
-              </a:rPr>
-              <a:t>Contact details: Tel: 0917 555 0101 | Email: rosa.lim@gasion.example</a:t>
-            </a:r>
-            <a:endParaRPr lang="en-US" sz="950" dirty="0"/>
-          </a:p>
-        </p:txBody>
-      </p:sp>
-      <p:sp>
-        <p:nvSpPr>
           <p:cNvPr id="15" name="Delivery heading"/>
           <p:cNvSpPr txBox="1"/>
           <p:nvPr/>
         </p:nvSpPr>
         <p:spPr>
           <a:xfrm>
-            <a:off x="457200" y="4247804"/>
+            <a:off x="3781044" y="2439508"/>
             <a:ext cx="2493818" cy="149629"/>
           </a:xfrm>
           <a:prstGeom prst="rect">
@@ -1513,7 +1291,7 @@
           <a:bodyPr wrap="square" lIns="0" tIns="0" rIns="0" bIns="0" rtlCol="0" anchor="t"/>
           <a:lstStyle/>
           <a:p>
-            <a:pPr indent="0" marL="0">
+            <a:pPr marL="0" indent="0">
               <a:buNone/>
             </a:pPr>
             <a:r>
@@ -1533,137 +1311,13 @@
       </p:sp>
       <p:sp>
         <p:nvSpPr>
-          <p:cNvPr id="16" name="Delivery left"/>
-          <p:cNvSpPr txBox="1"/>
-          <p:nvPr/>
-        </p:nvSpPr>
-        <p:spPr>
-          <a:xfrm>
-            <a:off x="457200" y="4530436"/>
-            <a:ext cx="3158836" cy="382385"/>
-          </a:xfrm>
-          <a:prstGeom prst="rect">
-            <a:avLst/>
-          </a:prstGeom>
-          <a:noFill/>
-          <a:ln/>
-        </p:spPr>
-        <p:txBody>
-          <a:bodyPr wrap="square" lIns="0" tIns="0" rIns="0" bIns="0" rtlCol="0" anchor="t"/>
-          <a:lstStyle/>
-          <a:p>
-            <a:pPr indent="0" marL="0">
-              <a:lnSpc>
-                <a:spcPct val="130000"/>
-              </a:lnSpc>
-              <a:buNone/>
-            </a:pPr>
-            <a:r>
-              <a:rPr lang="en-US" sz="950" b="1" dirty="0">
-                <a:solidFill>
-                  <a:srgbClr val="222222"/>
-                </a:solidFill>
-                <a:latin typeface="Arial" pitchFamily="34" charset="0"/>
-                <a:ea typeface="Arial" pitchFamily="34" charset="-122"/>
-                <a:cs typeface="Arial" pitchFamily="34" charset="-120"/>
-              </a:rPr>
-              <a:t>Deliver to: Main Warehouse</a:t>
-            </a:r>
-            <a:endParaRPr lang="en-US" sz="950" dirty="0"/>
-          </a:p>
-          <a:p>
-            <a:pPr indent="0" marL="0">
-              <a:lnSpc>
-                <a:spcPct val="130000"/>
-              </a:lnSpc>
-              <a:buNone/>
-            </a:pPr>
-            <a:r>
-              <a:rPr lang="en-US" sz="950" b="1" dirty="0">
-                <a:solidFill>
-                  <a:srgbClr val="222222"/>
-                </a:solidFill>
-                <a:latin typeface="Arial" pitchFamily="34" charset="0"/>
-                <a:ea typeface="Arial" pitchFamily="34" charset="-122"/>
-                <a:cs typeface="Arial" pitchFamily="34" charset="-120"/>
-              </a:rPr>
-              <a:t>Purchase request: —</a:t>
-            </a:r>
-            <a:endParaRPr lang="en-US" sz="950" dirty="0"/>
-          </a:p>
-        </p:txBody>
-      </p:sp>
-      <p:sp>
-        <p:nvSpPr>
-          <p:cNvPr id="17" name="Delivery right"/>
-          <p:cNvSpPr txBox="1"/>
-          <p:nvPr/>
-        </p:nvSpPr>
-        <p:spPr>
-          <a:xfrm>
-            <a:off x="3782291" y="4530436"/>
-            <a:ext cx="3325091" cy="382385"/>
-          </a:xfrm>
-          <a:prstGeom prst="rect">
-            <a:avLst/>
-          </a:prstGeom>
-          <a:noFill/>
-          <a:ln/>
-        </p:spPr>
-        <p:txBody>
-          <a:bodyPr wrap="square" lIns="0" tIns="0" rIns="0" bIns="0" rtlCol="0" anchor="t"/>
-          <a:lstStyle/>
-          <a:p>
-            <a:pPr indent="0" marL="0">
-              <a:lnSpc>
-                <a:spcPct val="130000"/>
-              </a:lnSpc>
-              <a:buNone/>
-            </a:pPr>
-            <a:r>
-              <a:rPr lang="en-US" sz="950" b="1" dirty="0">
-                <a:solidFill>
-                  <a:srgbClr val="222222"/>
-                </a:solidFill>
-                <a:latin typeface="Arial" pitchFamily="34" charset="0"/>
-                <a:ea typeface="Arial" pitchFamily="34" charset="-122"/>
-                <a:cs typeface="Arial" pitchFamily="34" charset="-120"/>
-              </a:rPr>
-              <a:t>Terms: —</a:t>
-            </a:r>
-            <a:endParaRPr lang="en-US" sz="950" dirty="0"/>
-          </a:p>
-          <a:p>
-            <a:pPr indent="0" marL="0">
-              <a:lnSpc>
-                <a:spcPct val="130000"/>
-              </a:lnSpc>
-              <a:buNone/>
-            </a:pPr>
-            <a:r>
-              <a:rPr lang="en-US" sz="950" b="1" dirty="0">
-                <a:solidFill>
-                  <a:srgbClr val="222222"/>
-                </a:solidFill>
-                <a:latin typeface="Arial" pitchFamily="34" charset="0"/>
-                <a:ea typeface="Arial" pitchFamily="34" charset="-122"/>
-                <a:cs typeface="Arial" pitchFamily="34" charset="-120"/>
-              </a:rPr>
-              <a:t>Status: Issued</a:t>
-            </a:r>
-            <a:endParaRPr lang="en-US" sz="950" dirty="0"/>
-          </a:p>
-        </p:txBody>
-      </p:sp>
-      <p:sp>
-        <p:nvSpPr>
           <p:cNvPr id="18" name="Order heading"/>
           <p:cNvSpPr txBox="1"/>
           <p:nvPr/>
         </p:nvSpPr>
         <p:spPr>
           <a:xfrm>
-            <a:off x="457200" y="5037513"/>
+            <a:off x="457200" y="3777673"/>
             <a:ext cx="2493818" cy="149629"/>
           </a:xfrm>
           <a:prstGeom prst="rect">
@@ -1676,7 +1330,7 @@
           <a:bodyPr wrap="square" lIns="0" tIns="0" rIns="0" bIns="0" rtlCol="0" anchor="t"/>
           <a:lstStyle/>
           <a:p>
-            <a:pPr indent="0" marL="0">
+            <a:pPr marL="0" indent="0">
               <a:buNone/>
             </a:pPr>
             <a:r>
@@ -1696,34 +1350,76 @@
       </p:sp>
       <p:graphicFrame>
         <p:nvGraphicFramePr>
-          <p:cNvPr id="2" name="Order lines"/>
+          <p:cNvPr id="19" name="Order lines"/>
           <p:cNvGraphicFramePr>
             <a:graphicFrameLocks noGrp="1"/>
           </p:cNvGraphicFramePr>
           <p:nvPr>
             <p:extLst>
               <p:ext uri="{D42A27DB-BD31-4B8C-83A1-F6EECF244321}">
-                <p14:modId xmlns:p14="http://schemas.microsoft.com/office/powerpoint/2010/main" val="1579011935"/>
+                <p14:modId xmlns:p14="http://schemas.microsoft.com/office/powerpoint/2010/main" val="3545928576"/>
               </p:ext>
             </p:extLst>
           </p:nvPr>
         </p:nvGraphicFramePr>
         <p:xfrm>
-          <a:off x="457200" y="5336771"/>
-          <a:ext cx="6650182" cy="914400"/>
+          <a:off x="457200" y="4076931"/>
+          <a:ext cx="6647688" cy="768096"/>
         </p:xfrm>
         <a:graphic>
           <a:graphicData uri="http://schemas.openxmlformats.org/drawingml/2006/table">
             <a:tbl>
               <a:tblPr/>
               <a:tblGrid>
-                <a:gridCol w="411480"/>
-                <a:gridCol w="777240"/>
-                <a:gridCol w="2103120"/>
-                <a:gridCol w="457200"/>
-                <a:gridCol w="640080"/>
-                <a:gridCol w="1234440"/>
-                <a:gridCol w="1024128"/>
+                <a:gridCol w="411480">
+                  <a:extLst>
+                    <a:ext uri="{9D8B030D-6E8A-4147-A177-3AD203B41FA5}">
+                      <a16:colId xmlns:a16="http://schemas.microsoft.com/office/drawing/2014/main" val="20000"/>
+                    </a:ext>
+                  </a:extLst>
+                </a:gridCol>
+                <a:gridCol w="777240">
+                  <a:extLst>
+                    <a:ext uri="{9D8B030D-6E8A-4147-A177-3AD203B41FA5}">
+                      <a16:colId xmlns:a16="http://schemas.microsoft.com/office/drawing/2014/main" val="20001"/>
+                    </a:ext>
+                  </a:extLst>
+                </a:gridCol>
+                <a:gridCol w="2103120">
+                  <a:extLst>
+                    <a:ext uri="{9D8B030D-6E8A-4147-A177-3AD203B41FA5}">
+                      <a16:colId xmlns:a16="http://schemas.microsoft.com/office/drawing/2014/main" val="20002"/>
+                    </a:ext>
+                  </a:extLst>
+                </a:gridCol>
+                <a:gridCol w="457200">
+                  <a:extLst>
+                    <a:ext uri="{9D8B030D-6E8A-4147-A177-3AD203B41FA5}">
+                      <a16:colId xmlns:a16="http://schemas.microsoft.com/office/drawing/2014/main" val="20003"/>
+                    </a:ext>
+                  </a:extLst>
+                </a:gridCol>
+                <a:gridCol w="640080">
+                  <a:extLst>
+                    <a:ext uri="{9D8B030D-6E8A-4147-A177-3AD203B41FA5}">
+                      <a16:colId xmlns:a16="http://schemas.microsoft.com/office/drawing/2014/main" val="20004"/>
+                    </a:ext>
+                  </a:extLst>
+                </a:gridCol>
+                <a:gridCol w="1234440">
+                  <a:extLst>
+                    <a:ext uri="{9D8B030D-6E8A-4147-A177-3AD203B41FA5}">
+                      <a16:colId xmlns:a16="http://schemas.microsoft.com/office/drawing/2014/main" val="20005"/>
+                    </a:ext>
+                  </a:extLst>
+                </a:gridCol>
+                <a:gridCol w="1024128">
+                  <a:extLst>
+                    <a:ext uri="{9D8B030D-6E8A-4147-A177-3AD203B41FA5}">
+                      <a16:colId xmlns:a16="http://schemas.microsoft.com/office/drawing/2014/main" val="20006"/>
+                    </a:ext>
+                  </a:extLst>
+                </a:gridCol>
               </a:tblGrid>
               <a:tr h="384048">
                 <a:tc>
@@ -1731,7 +1427,7 @@
                     <a:bodyPr/>
                     <a:lstStyle/>
                     <a:p>
-                      <a:pPr algn="r" indent="0" marL="0">
+                      <a:pPr marL="0" indent="0" algn="r">
                         <a:buNone/>
                       </a:pPr>
                       <a:r>
@@ -1752,7 +1448,7 @@
                       </a:endParaRPr>
                     </a:p>
                   </a:txBody>
-                  <a:tcPr marL="91440" marR="91440" marT="45720" marB="45720" anchor="ctr">
+                  <a:tcPr anchor="ctr">
                     <a:lnL w="0" cap="flat" cmpd="sng" algn="ctr">
                       <a:noFill/>
                     </a:lnL>
@@ -1778,7 +1474,7 @@
                     <a:bodyPr/>
                     <a:lstStyle/>
                     <a:p>
-                      <a:pPr algn="l" indent="0" marL="0">
+                      <a:pPr marL="0" indent="0" algn="l">
                         <a:buNone/>
                       </a:pPr>
                       <a:r>
@@ -1799,7 +1495,7 @@
                       </a:endParaRPr>
                     </a:p>
                   </a:txBody>
-                  <a:tcPr marL="91440" marR="91440" marT="45720" marB="45720" anchor="ctr">
+                  <a:tcPr anchor="ctr">
                     <a:lnL w="0" cap="flat" cmpd="sng" algn="ctr">
                       <a:noFill/>
                     </a:lnL>
@@ -1825,7 +1521,7 @@
                     <a:bodyPr/>
                     <a:lstStyle/>
                     <a:p>
-                      <a:pPr algn="l" indent="0" marL="0">
+                      <a:pPr marL="0" indent="0" algn="l">
                         <a:buNone/>
                       </a:pPr>
                       <a:r>
@@ -1846,7 +1542,7 @@
                       </a:endParaRPr>
                     </a:p>
                   </a:txBody>
-                  <a:tcPr marL="91440" marR="91440" marT="45720" marB="45720" anchor="ctr">
+                  <a:tcPr anchor="ctr">
                     <a:lnL w="0" cap="flat" cmpd="sng" algn="ctr">
                       <a:noFill/>
                     </a:lnL>
@@ -1872,7 +1568,7 @@
                     <a:bodyPr/>
                     <a:lstStyle/>
                     <a:p>
-                      <a:pPr algn="r" indent="0" marL="0">
+                      <a:pPr marL="0" indent="0" algn="r">
                         <a:buNone/>
                       </a:pPr>
                       <a:r>
@@ -1893,7 +1589,7 @@
                       </a:endParaRPr>
                     </a:p>
                   </a:txBody>
-                  <a:tcPr marL="91440" marR="91440" marT="45720" marB="45720" anchor="ctr">
+                  <a:tcPr anchor="ctr">
                     <a:lnL w="0" cap="flat" cmpd="sng" algn="ctr">
                       <a:noFill/>
                     </a:lnL>
@@ -1919,7 +1615,7 @@
                     <a:bodyPr/>
                     <a:lstStyle/>
                     <a:p>
-                      <a:pPr algn="l" indent="0" marL="0">
+                      <a:pPr marL="0" indent="0" algn="l">
                         <a:buNone/>
                       </a:pPr>
                       <a:r>
@@ -1940,7 +1636,7 @@
                       </a:endParaRPr>
                     </a:p>
                   </a:txBody>
-                  <a:tcPr marL="91440" marR="91440" marT="45720" marB="45720" anchor="ctr">
+                  <a:tcPr anchor="ctr">
                     <a:lnL w="0" cap="flat" cmpd="sng" algn="ctr">
                       <a:noFill/>
                     </a:lnL>
@@ -1966,7 +1662,7 @@
                     <a:bodyPr/>
                     <a:lstStyle/>
                     <a:p>
-                      <a:pPr algn="r" indent="0" marL="0">
+                      <a:pPr marL="0" indent="0" algn="r">
                         <a:buNone/>
                       </a:pPr>
                       <a:r>
@@ -1987,7 +1683,7 @@
                       </a:endParaRPr>
                     </a:p>
                   </a:txBody>
-                  <a:tcPr marL="91440" marR="91440" marT="45720" marB="45720" anchor="ctr">
+                  <a:tcPr anchor="ctr">
                     <a:lnL w="0" cap="flat" cmpd="sng" algn="ctr">
                       <a:noFill/>
                     </a:lnL>
@@ -2013,7 +1709,7 @@
                     <a:bodyPr/>
                     <a:lstStyle/>
                     <a:p>
-                      <a:pPr algn="r" indent="0" marL="0">
+                      <a:pPr marL="0" indent="0" algn="r">
                         <a:buNone/>
                       </a:pPr>
                       <a:r>
@@ -2034,7 +1730,7 @@
                       </a:endParaRPr>
                     </a:p>
                   </a:txBody>
-                  <a:tcPr marL="91440" marR="91440" marT="45720" marB="45720" anchor="ctr">
+                  <a:tcPr anchor="ctr">
                     <a:lnL w="0" cap="flat" cmpd="sng" algn="ctr">
                       <a:noFill/>
                     </a:lnL>
@@ -2055,6 +1751,11 @@
                     </a:lnB>
                   </a:tcPr>
                 </a:tc>
+                <a:extLst>
+                  <a:ext uri="{0D108BD9-81ED-4DB2-BD59-A6C34878D82A}">
+                    <a16:rowId xmlns:a16="http://schemas.microsoft.com/office/drawing/2014/main" val="10000"/>
+                  </a:ext>
+                </a:extLst>
               </a:tr>
               <a:tr h="384048">
                 <a:tc>
@@ -2062,7 +1763,7 @@
                     <a:bodyPr/>
                     <a:lstStyle/>
                     <a:p>
-                      <a:pPr algn="r" indent="0" marL="0">
+                      <a:pPr marL="0" indent="0" algn="r">
                         <a:buNone/>
                       </a:pPr>
                       <a:r>
@@ -2083,15 +1784,21 @@
                       </a:endParaRPr>
                     </a:p>
                   </a:txBody>
-                  <a:tcPr marL="91440" marR="91440" marT="45720" marB="45720" anchor="ctr">
+                  <a:tcPr anchor="ctr">
                     <a:lnL w="0" cap="flat" cmpd="sng" algn="ctr">
                       <a:noFill/>
                     </a:lnL>
                     <a:lnR w="0" cap="flat" cmpd="sng" algn="ctr">
                       <a:noFill/>
                     </a:lnR>
-                    <a:lnT w="0" cap="flat" cmpd="sng" algn="ctr">
-                      <a:noFill/>
+                    <a:lnT w="9525" cap="flat" cmpd="sng" algn="ctr">
+                      <a:solidFill>
+                        <a:srgbClr val="D9D9D9"/>
+                      </a:solidFill>
+                      <a:prstDash val="solid"/>
+                      <a:round/>
+                      <a:headEnd type="none" w="med" len="med"/>
+                      <a:tailEnd type="none" w="med" len="med"/>
                     </a:lnT>
                     <a:lnB w="9525" cap="flat" cmpd="sng" algn="ctr">
                       <a:solidFill>
@@ -2109,7 +1816,7 @@
                     <a:bodyPr/>
                     <a:lstStyle/>
                     <a:p>
-                      <a:pPr algn="l" indent="0" marL="0">
+                      <a:pPr marL="0" indent="0" algn="l">
                         <a:buNone/>
                       </a:pPr>
                       <a:endParaRPr lang="en-US" sz="950" dirty="0">
@@ -2119,15 +1826,21 @@
                       </a:endParaRPr>
                     </a:p>
                   </a:txBody>
-                  <a:tcPr marL="91440" marR="91440" marT="45720" marB="45720" anchor="ctr">
+                  <a:tcPr anchor="ctr">
                     <a:lnL w="0" cap="flat" cmpd="sng" algn="ctr">
                       <a:noFill/>
                     </a:lnL>
                     <a:lnR w="0" cap="flat" cmpd="sng" algn="ctr">
                       <a:noFill/>
                     </a:lnR>
-                    <a:lnT w="0" cap="flat" cmpd="sng" algn="ctr">
-                      <a:noFill/>
+                    <a:lnT w="9525" cap="flat" cmpd="sng" algn="ctr">
+                      <a:solidFill>
+                        <a:srgbClr val="D9D9D9"/>
+                      </a:solidFill>
+                      <a:prstDash val="solid"/>
+                      <a:round/>
+                      <a:headEnd type="none" w="med" len="med"/>
+                      <a:tailEnd type="none" w="med" len="med"/>
                     </a:lnT>
                     <a:lnB w="9525" cap="flat" cmpd="sng" algn="ctr">
                       <a:solidFill>
@@ -2145,7 +1858,7 @@
                     <a:bodyPr/>
                     <a:lstStyle/>
                     <a:p>
-                      <a:pPr algn="l" indent="0" marL="0">
+                      <a:pPr marL="0" indent="0" algn="l">
                         <a:buNone/>
                       </a:pPr>
                       <a:r>
@@ -2166,15 +1879,21 @@
                       </a:endParaRPr>
                     </a:p>
                   </a:txBody>
-                  <a:tcPr marL="91440" marR="91440" marT="45720" marB="45720" anchor="ctr">
+                  <a:tcPr anchor="ctr">
                     <a:lnL w="0" cap="flat" cmpd="sng" algn="ctr">
                       <a:noFill/>
                     </a:lnL>
                     <a:lnR w="0" cap="flat" cmpd="sng" algn="ctr">
                       <a:noFill/>
                     </a:lnR>
-                    <a:lnT w="0" cap="flat" cmpd="sng" algn="ctr">
-                      <a:noFill/>
+                    <a:lnT w="9525" cap="flat" cmpd="sng" algn="ctr">
+                      <a:solidFill>
+                        <a:srgbClr val="D9D9D9"/>
+                      </a:solidFill>
+                      <a:prstDash val="solid"/>
+                      <a:round/>
+                      <a:headEnd type="none" w="med" len="med"/>
+                      <a:tailEnd type="none" w="med" len="med"/>
                     </a:lnT>
                     <a:lnB w="9525" cap="flat" cmpd="sng" algn="ctr">
                       <a:solidFill>
@@ -2192,7 +1911,7 @@
                     <a:bodyPr/>
                     <a:lstStyle/>
                     <a:p>
-                      <a:pPr algn="r" indent="0" marL="0">
+                      <a:pPr marL="0" indent="0" algn="r">
                         <a:buNone/>
                       </a:pPr>
                       <a:r>
@@ -2213,15 +1932,21 @@
                       </a:endParaRPr>
                     </a:p>
                   </a:txBody>
-                  <a:tcPr marL="91440" marR="91440" marT="45720" marB="45720" anchor="ctr">
+                  <a:tcPr anchor="ctr">
                     <a:lnL w="0" cap="flat" cmpd="sng" algn="ctr">
                       <a:noFill/>
                     </a:lnL>
                     <a:lnR w="0" cap="flat" cmpd="sng" algn="ctr">
                       <a:noFill/>
                     </a:lnR>
-                    <a:lnT w="0" cap="flat" cmpd="sng" algn="ctr">
-                      <a:noFill/>
+                    <a:lnT w="9525" cap="flat" cmpd="sng" algn="ctr">
+                      <a:solidFill>
+                        <a:srgbClr val="D9D9D9"/>
+                      </a:solidFill>
+                      <a:prstDash val="solid"/>
+                      <a:round/>
+                      <a:headEnd type="none" w="med" len="med"/>
+                      <a:tailEnd type="none" w="med" len="med"/>
                     </a:lnT>
                     <a:lnB w="9525" cap="flat" cmpd="sng" algn="ctr">
                       <a:solidFill>
@@ -2239,7 +1964,7 @@
                     <a:bodyPr/>
                     <a:lstStyle/>
                     <a:p>
-                      <a:pPr algn="l" indent="0" marL="0">
+                      <a:pPr marL="0" indent="0" algn="l">
                         <a:buNone/>
                       </a:pPr>
                       <a:r>
@@ -2260,15 +1985,21 @@
                       </a:endParaRPr>
                     </a:p>
                   </a:txBody>
-                  <a:tcPr marL="91440" marR="91440" marT="45720" marB="45720" anchor="ctr">
+                  <a:tcPr anchor="ctr">
                     <a:lnL w="0" cap="flat" cmpd="sng" algn="ctr">
                       <a:noFill/>
                     </a:lnL>
                     <a:lnR w="0" cap="flat" cmpd="sng" algn="ctr">
                       <a:noFill/>
                     </a:lnR>
-                    <a:lnT w="0" cap="flat" cmpd="sng" algn="ctr">
-                      <a:noFill/>
+                    <a:lnT w="9525" cap="flat" cmpd="sng" algn="ctr">
+                      <a:solidFill>
+                        <a:srgbClr val="D9D9D9"/>
+                      </a:solidFill>
+                      <a:prstDash val="solid"/>
+                      <a:round/>
+                      <a:headEnd type="none" w="med" len="med"/>
+                      <a:tailEnd type="none" w="med" len="med"/>
                     </a:lnT>
                     <a:lnB w="9525" cap="flat" cmpd="sng" algn="ctr">
                       <a:solidFill>
@@ -2286,7 +2017,7 @@
                     <a:bodyPr/>
                     <a:lstStyle/>
                     <a:p>
-                      <a:pPr algn="r" indent="0" marL="0">
+                      <a:pPr marL="0" indent="0" algn="r">
                         <a:buNone/>
                       </a:pPr>
                       <a:r>
@@ -2307,15 +2038,21 @@
                       </a:endParaRPr>
                     </a:p>
                   </a:txBody>
-                  <a:tcPr marL="91440" marR="91440" marT="45720" marB="45720" anchor="ctr">
+                  <a:tcPr anchor="ctr">
                     <a:lnL w="0" cap="flat" cmpd="sng" algn="ctr">
                       <a:noFill/>
                     </a:lnL>
                     <a:lnR w="0" cap="flat" cmpd="sng" algn="ctr">
                       <a:noFill/>
                     </a:lnR>
-                    <a:lnT w="0" cap="flat" cmpd="sng" algn="ctr">
-                      <a:noFill/>
+                    <a:lnT w="9525" cap="flat" cmpd="sng" algn="ctr">
+                      <a:solidFill>
+                        <a:srgbClr val="D9D9D9"/>
+                      </a:solidFill>
+                      <a:prstDash val="solid"/>
+                      <a:round/>
+                      <a:headEnd type="none" w="med" len="med"/>
+                      <a:tailEnd type="none" w="med" len="med"/>
                     </a:lnT>
                     <a:lnB w="9525" cap="flat" cmpd="sng" algn="ctr">
                       <a:solidFill>
@@ -2333,7 +2070,7 @@
                     <a:bodyPr/>
                     <a:lstStyle/>
                     <a:p>
-                      <a:pPr algn="r" indent="0" marL="0">
+                      <a:pPr marL="0" indent="0" algn="r">
                         <a:buNone/>
                       </a:pPr>
                       <a:r>
@@ -2354,15 +2091,21 @@
                       </a:endParaRPr>
                     </a:p>
                   </a:txBody>
-                  <a:tcPr marL="91440" marR="91440" marT="45720" marB="45720" anchor="ctr">
+                  <a:tcPr anchor="ctr">
                     <a:lnL w="0" cap="flat" cmpd="sng" algn="ctr">
                       <a:noFill/>
                     </a:lnL>
                     <a:lnR w="0" cap="flat" cmpd="sng" algn="ctr">
                       <a:noFill/>
                     </a:lnR>
-                    <a:lnT w="0" cap="flat" cmpd="sng" algn="ctr">
-                      <a:noFill/>
+                    <a:lnT w="9525" cap="flat" cmpd="sng" algn="ctr">
+                      <a:solidFill>
+                        <a:srgbClr val="D9D9D9"/>
+                      </a:solidFill>
+                      <a:prstDash val="solid"/>
+                      <a:round/>
+                      <a:headEnd type="none" w="med" len="med"/>
+                      <a:tailEnd type="none" w="med" len="med"/>
                     </a:lnT>
                     <a:lnB w="9525" cap="flat" cmpd="sng" algn="ctr">
                       <a:solidFill>
@@ -2375,6 +2118,11 @@
                     </a:lnB>
                   </a:tcPr>
                 </a:tc>
+                <a:extLst>
+                  <a:ext uri="{0D108BD9-81ED-4DB2-BD59-A6C34878D82A}">
+                    <a16:rowId xmlns:a16="http://schemas.microsoft.com/office/drawing/2014/main" val="10001"/>
+                  </a:ext>
+                </a:extLst>
               </a:tr>
             </a:tbl>
           </a:graphicData>
@@ -2388,7 +2136,7 @@
         </p:nvSpPr>
         <p:spPr>
           <a:xfrm>
-            <a:off x="4247804" y="6417425"/>
+            <a:off x="4247804" y="5157585"/>
             <a:ext cx="1246909" cy="149629"/>
           </a:xfrm>
           <a:prstGeom prst="rect">
@@ -2401,7 +2149,7 @@
           <a:bodyPr wrap="square" lIns="0" tIns="0" rIns="0" bIns="0" rtlCol="0" anchor="t"/>
           <a:lstStyle/>
           <a:p>
-            <a:pPr indent="0" marL="0">
+            <a:pPr marL="0" indent="0">
               <a:buNone/>
             </a:pPr>
             <a:r>
@@ -2427,7 +2175,7 @@
         </p:nvSpPr>
         <p:spPr>
           <a:xfrm>
-            <a:off x="5735782" y="6417425"/>
+            <a:off x="5735782" y="5157585"/>
             <a:ext cx="1280160" cy="149629"/>
           </a:xfrm>
           <a:prstGeom prst="rect">
@@ -2440,7 +2188,7 @@
           <a:bodyPr wrap="square" lIns="0" tIns="0" rIns="0" bIns="0" rtlCol="0" anchor="t"/>
           <a:lstStyle/>
           <a:p>
-            <a:pPr algn="r" indent="0" marL="0">
+            <a:pPr marL="0" indent="0" algn="r">
               <a:buNone/>
             </a:pPr>
             <a:r>
@@ -2466,7 +2214,7 @@
         </p:nvSpPr>
         <p:spPr>
           <a:xfrm>
-            <a:off x="4156364" y="6658495"/>
+            <a:off x="4156364" y="5398655"/>
             <a:ext cx="2951018" cy="0"/>
           </a:xfrm>
           <a:prstGeom prst="line">
@@ -2489,7 +2237,7 @@
         </p:nvSpPr>
         <p:spPr>
           <a:xfrm>
-            <a:off x="4247804" y="6724996"/>
+            <a:off x="4247804" y="5465156"/>
             <a:ext cx="1246909" cy="149629"/>
           </a:xfrm>
           <a:prstGeom prst="rect">
@@ -2502,7 +2250,7 @@
           <a:bodyPr wrap="square" lIns="0" tIns="0" rIns="0" bIns="0" rtlCol="0" anchor="t"/>
           <a:lstStyle/>
           <a:p>
-            <a:pPr indent="0" marL="0">
+            <a:pPr marL="0" indent="0">
               <a:buNone/>
             </a:pPr>
             <a:r>
@@ -2528,7 +2276,7 @@
         </p:nvSpPr>
         <p:spPr>
           <a:xfrm>
-            <a:off x="5735782" y="6724996"/>
+            <a:off x="5735782" y="5465156"/>
             <a:ext cx="1280160" cy="149629"/>
           </a:xfrm>
           <a:prstGeom prst="rect">
@@ -2541,7 +2289,7 @@
           <a:bodyPr wrap="square" lIns="0" tIns="0" rIns="0" bIns="0" rtlCol="0" anchor="t"/>
           <a:lstStyle/>
           <a:p>
-            <a:pPr algn="r" indent="0" marL="0">
+            <a:pPr marL="0" indent="0" algn="r">
               <a:buNone/>
             </a:pPr>
             <a:r>
@@ -2567,7 +2315,7 @@
         </p:nvSpPr>
         <p:spPr>
           <a:xfrm>
-            <a:off x="4156364" y="6966065"/>
+            <a:off x="4156364" y="5706225"/>
             <a:ext cx="2951018" cy="0"/>
           </a:xfrm>
           <a:prstGeom prst="line">
@@ -2590,7 +2338,7 @@
         </p:nvSpPr>
         <p:spPr>
           <a:xfrm>
-            <a:off x="4247804" y="7057505"/>
+            <a:off x="4247804" y="5797665"/>
             <a:ext cx="1246909" cy="182880"/>
           </a:xfrm>
           <a:prstGeom prst="rect">
@@ -2603,7 +2351,7 @@
           <a:bodyPr wrap="square" lIns="0" tIns="0" rIns="0" bIns="0" rtlCol="0" anchor="t"/>
           <a:lstStyle/>
           <a:p>
-            <a:pPr indent="0" marL="0">
+            <a:pPr marL="0" indent="0">
               <a:buNone/>
             </a:pPr>
             <a:r>
@@ -2629,7 +2377,7 @@
         </p:nvSpPr>
         <p:spPr>
           <a:xfrm>
-            <a:off x="5569527" y="7057505"/>
+            <a:off x="5569527" y="5797665"/>
             <a:ext cx="1446415" cy="182880"/>
           </a:xfrm>
           <a:prstGeom prst="rect">
@@ -2642,7 +2390,7 @@
           <a:bodyPr wrap="square" lIns="0" tIns="0" rIns="0" bIns="0" rtlCol="0" anchor="t"/>
           <a:lstStyle/>
           <a:p>
-            <a:pPr algn="r" indent="0" marL="0">
+            <a:pPr marL="0" indent="0" algn="r">
               <a:buNone/>
             </a:pPr>
             <a:r>
@@ -2668,7 +2416,7 @@
         </p:nvSpPr>
         <p:spPr>
           <a:xfrm>
-            <a:off x="4156364" y="7348451"/>
+            <a:off x="4156364" y="6088611"/>
             <a:ext cx="2951018" cy="0"/>
           </a:xfrm>
           <a:prstGeom prst="line">
@@ -2691,7 +2439,7 @@
         </p:nvSpPr>
         <p:spPr>
           <a:xfrm>
-            <a:off x="457200" y="7523018"/>
+            <a:off x="457200" y="6263178"/>
             <a:ext cx="2493818" cy="149629"/>
           </a:xfrm>
           <a:prstGeom prst="rect">
@@ -2704,7 +2452,7 @@
           <a:bodyPr wrap="square" lIns="0" tIns="0" rIns="0" bIns="0" rtlCol="0" anchor="t"/>
           <a:lstStyle/>
           <a:p>
-            <a:pPr indent="0" marL="0">
+            <a:pPr marL="0" indent="0">
               <a:buNone/>
             </a:pPr>
             <a:r>
@@ -2730,7 +2478,7 @@
         </p:nvSpPr>
         <p:spPr>
           <a:xfrm>
-            <a:off x="457200" y="7797338"/>
+            <a:off x="457200" y="6537498"/>
             <a:ext cx="4156364" cy="149629"/>
           </a:xfrm>
           <a:prstGeom prst="rect">
@@ -2743,7 +2491,7 @@
           <a:bodyPr wrap="square" lIns="0" tIns="0" rIns="0" bIns="0" rtlCol="0" anchor="t"/>
           <a:lstStyle/>
           <a:p>
-            <a:pPr indent="0" marL="0">
+            <a:pPr marL="0" indent="0">
               <a:buNone/>
             </a:pPr>
             <a:r>
@@ -2769,7 +2517,7 @@
         </p:nvSpPr>
         <p:spPr>
           <a:xfrm>
-            <a:off x="457200" y="8936182"/>
+            <a:off x="457200" y="8672022"/>
             <a:ext cx="6650182" cy="0"/>
           </a:xfrm>
           <a:prstGeom prst="line">
@@ -2805,7 +2553,7 @@
           <a:bodyPr wrap="square" lIns="0" tIns="0" rIns="0" bIns="0" rtlCol="0" anchor="t"/>
           <a:lstStyle/>
           <a:p>
-            <a:pPr indent="0" marL="0">
+            <a:pPr marL="0" indent="0">
               <a:buNone/>
             </a:pPr>
             <a:r>
@@ -2844,7 +2592,7 @@
           <a:bodyPr wrap="square" lIns="0" tIns="0" rIns="0" bIns="0" rtlCol="0" anchor="t"/>
           <a:lstStyle/>
           <a:p>
-            <a:pPr indent="0" marL="0">
+            <a:pPr marL="0" indent="0">
               <a:buNone/>
             </a:pPr>
             <a:r>
@@ -2861,7 +2609,7 @@
             <a:endParaRPr lang="en-US" sz="950" dirty="0"/>
           </a:p>
           <a:p>
-            <a:pPr indent="0" marL="0">
+            <a:pPr marL="0" indent="0">
               <a:buNone/>
             </a:pPr>
             <a:r>
@@ -2878,7 +2626,7 @@
             <a:endParaRPr lang="en-US" sz="950" dirty="0"/>
           </a:p>
           <a:p>
-            <a:pPr indent="0" marL="0">
+            <a:pPr marL="0" indent="0">
               <a:buNone/>
             </a:pPr>
             <a:r>
@@ -2917,7 +2665,7 @@
           <a:bodyPr wrap="square" lIns="0" tIns="0" rIns="0" bIns="0" rtlCol="0" anchor="t"/>
           <a:lstStyle/>
           <a:p>
-            <a:pPr indent="0" marL="0">
+            <a:pPr marL="0" indent="0">
               <a:buNone/>
             </a:pPr>
             <a:r>
@@ -2956,7 +2704,7 @@
           <a:bodyPr wrap="square" lIns="0" tIns="0" rIns="0" bIns="0" rtlCol="0" anchor="t"/>
           <a:lstStyle/>
           <a:p>
-            <a:pPr indent="0" marL="0">
+            <a:pPr marL="0" indent="0">
               <a:buNone/>
             </a:pPr>
             <a:r>
@@ -3018,11 +2766,11 @@
           <a:bodyPr wrap="square" lIns="0" tIns="0" rIns="0" bIns="0" rtlCol="0" anchor="t"/>
           <a:lstStyle/>
           <a:p>
-            <a:pPr algn="ctr" indent="0" marL="0">
+            <a:pPr marL="0" indent="0" algn="ctr">
               <a:buNone/>
             </a:pPr>
             <a:r>
-              <a:rPr lang="en-US" sz="1300" b="1" spc="150" kern="0" dirty="0">
+              <a:rPr lang="en-US" sz="1300" b="1" kern="0" spc="150" dirty="0">
                 <a:solidFill>
                   <a:srgbClr val="2E9A4B"/>
                 </a:solidFill>
@@ -3030,9 +2778,249 @@
                 <a:ea typeface="Arial" pitchFamily="34" charset="-122"/>
                 <a:cs typeface="Arial" pitchFamily="34" charset="-120"/>
               </a:rPr>
-              <a:t>INDUSTRIAL UTILITY SOLUTIONS   WWW.GRUNTECHNOLOGY.COM</a:t>
+              <a:t>INDUSTRIAL UTILITY SOLUTIONS</a:t>
             </a:r>
             <a:endParaRPr lang="en-US" sz="1300" dirty="0"/>
+          </a:p>
+        </p:txBody>
+      </p:sp>
+      <p:sp>
+        <p:nvSpPr>
+          <p:cNvPr id="39" name="Details">
+            <a:extLst>
+              <a:ext uri="{FF2B5EF4-FFF2-40B4-BE49-F238E27FC236}">
+                <a16:creationId xmlns:a16="http://schemas.microsoft.com/office/drawing/2014/main" id="{74D00973-A306-76F2-22CF-F07CF6E78406}"/>
+              </a:ext>
+            </a:extLst>
+          </p:cNvPr>
+          <p:cNvSpPr txBox="1"/>
+          <p:nvPr/>
+        </p:nvSpPr>
+        <p:spPr>
+          <a:xfrm>
+            <a:off x="3782291" y="2102195"/>
+            <a:ext cx="3325091" cy="224445"/>
+          </a:xfrm>
+          <a:prstGeom prst="rect">
+            <a:avLst/>
+          </a:prstGeom>
+          <a:noFill/>
+          <a:ln/>
+        </p:spPr>
+        <p:txBody>
+          <a:bodyPr wrap="square" lIns="0" tIns="0" rIns="0" bIns="0" rtlCol="0" anchor="t"/>
+          <a:lstStyle/>
+          <a:p>
+            <a:pPr marL="0" indent="0">
+              <a:lnSpc>
+                <a:spcPct val="130000"/>
+              </a:lnSpc>
+              <a:buNone/>
+            </a:pPr>
+            <a:r>
+              <a:rPr lang="en-US" sz="950" b="1" dirty="0">
+                <a:solidFill>
+                  <a:srgbClr val="222222"/>
+                </a:solidFill>
+                <a:latin typeface="Arial" pitchFamily="34" charset="0"/>
+                <a:ea typeface="Arial" pitchFamily="34" charset="-122"/>
+                <a:cs typeface="Arial" pitchFamily="34" charset="-120"/>
+              </a:rPr>
+              <a:t>Delivery date: October 28, 2026</a:t>
+            </a:r>
+            <a:endParaRPr lang="en-US" sz="950" dirty="0"/>
+          </a:p>
+        </p:txBody>
+      </p:sp>
+      <p:sp>
+        <p:nvSpPr>
+          <p:cNvPr id="41" name="Supplier left">
+            <a:extLst>
+              <a:ext uri="{FF2B5EF4-FFF2-40B4-BE49-F238E27FC236}">
+                <a16:creationId xmlns:a16="http://schemas.microsoft.com/office/drawing/2014/main" id="{F0EA716B-43C8-A9E1-55AB-5DD95D70C34D}"/>
+              </a:ext>
+            </a:extLst>
+          </p:cNvPr>
+          <p:cNvSpPr txBox="1"/>
+          <p:nvPr/>
+        </p:nvSpPr>
+        <p:spPr>
+          <a:xfrm>
+            <a:off x="3782291" y="2655455"/>
+            <a:ext cx="3158836" cy="882072"/>
+          </a:xfrm>
+          <a:prstGeom prst="rect">
+            <a:avLst/>
+          </a:prstGeom>
+          <a:noFill/>
+          <a:ln/>
+        </p:spPr>
+        <p:txBody>
+          <a:bodyPr wrap="square" lIns="0" tIns="0" rIns="0" bIns="0" rtlCol="0" anchor="t"/>
+          <a:lstStyle/>
+          <a:p>
+            <a:pPr marL="0" indent="0">
+              <a:buNone/>
+            </a:pPr>
+            <a:r>
+              <a:rPr lang="en-US" sz="950" b="1" dirty="0">
+                <a:solidFill>
+                  <a:srgbClr val="222222"/>
+                </a:solidFill>
+                <a:latin typeface="Arial" pitchFamily="34" charset="0"/>
+                <a:ea typeface="Arial" pitchFamily="34" charset="-122"/>
+                <a:cs typeface="Arial" pitchFamily="34" charset="-120"/>
+              </a:rPr>
+              <a:t>GRUNTECHNOLOGY CORPORATION</a:t>
+            </a:r>
+            <a:br>
+              <a:rPr lang="en-US" sz="950" b="1" dirty="0">
+                <a:solidFill>
+                  <a:srgbClr val="222222"/>
+                </a:solidFill>
+                <a:latin typeface="Arial" pitchFamily="34" charset="0"/>
+                <a:ea typeface="Arial" pitchFamily="34" charset="-122"/>
+                <a:cs typeface="Arial" pitchFamily="34" charset="-120"/>
+              </a:rPr>
+            </a:br>
+            <a:r>
+              <a:rPr lang="en-US" sz="950" b="1" dirty="0">
+                <a:solidFill>
+                  <a:srgbClr val="222222"/>
+                </a:solidFill>
+                <a:latin typeface="Arial" pitchFamily="34" charset="0"/>
+                <a:ea typeface="Arial" pitchFamily="34" charset="-122"/>
+                <a:cs typeface="Arial" pitchFamily="34" charset="-120"/>
+              </a:rPr>
+              <a:t>#2 Rajah Soliman Street </a:t>
+            </a:r>
+            <a:br>
+              <a:rPr lang="en-US" sz="950" b="1" dirty="0">
+                <a:solidFill>
+                  <a:srgbClr val="222222"/>
+                </a:solidFill>
+                <a:latin typeface="Arial" pitchFamily="34" charset="0"/>
+                <a:ea typeface="Arial" pitchFamily="34" charset="-122"/>
+                <a:cs typeface="Arial" pitchFamily="34" charset="-120"/>
+              </a:rPr>
+            </a:br>
+            <a:r>
+              <a:rPr lang="en-US" sz="950" b="1" dirty="0">
+                <a:solidFill>
+                  <a:srgbClr val="222222"/>
+                </a:solidFill>
+                <a:latin typeface="Arial" pitchFamily="34" charset="0"/>
+                <a:ea typeface="Arial" pitchFamily="34" charset="-122"/>
+                <a:cs typeface="Arial" pitchFamily="34" charset="-120"/>
+              </a:rPr>
+              <a:t>Barangay Parang Marikina City</a:t>
+            </a:r>
+            <a:br>
+              <a:rPr lang="en-US" sz="950" b="1" dirty="0">
+                <a:solidFill>
+                  <a:srgbClr val="222222"/>
+                </a:solidFill>
+                <a:latin typeface="Arial" pitchFamily="34" charset="0"/>
+                <a:ea typeface="Arial" pitchFamily="34" charset="-122"/>
+                <a:cs typeface="Arial" pitchFamily="34" charset="-120"/>
+              </a:rPr>
+            </a:br>
+            <a:r>
+              <a:rPr lang="en-US" sz="950" b="1" dirty="0">
+                <a:solidFill>
+                  <a:srgbClr val="222222"/>
+                </a:solidFill>
+                <a:latin typeface="Arial" pitchFamily="34" charset="0"/>
+                <a:ea typeface="Arial" pitchFamily="34" charset="-122"/>
+                <a:cs typeface="Arial" pitchFamily="34" charset="-120"/>
+              </a:rPr>
+              <a:t>+63286554063</a:t>
+            </a:r>
+            <a:br>
+              <a:rPr lang="en-US" sz="950" b="1" dirty="0">
+                <a:solidFill>
+                  <a:srgbClr val="222222"/>
+                </a:solidFill>
+                <a:latin typeface="Arial" pitchFamily="34" charset="0"/>
+                <a:ea typeface="Arial" pitchFamily="34" charset="-122"/>
+                <a:cs typeface="Arial" pitchFamily="34" charset="-120"/>
+              </a:rPr>
+            </a:br>
+            <a:r>
+              <a:rPr lang="en-US" sz="950" b="1" dirty="0">
+                <a:solidFill>
+                  <a:srgbClr val="222222"/>
+                </a:solidFill>
+                <a:latin typeface="Arial" pitchFamily="34" charset="0"/>
+                <a:ea typeface="Arial" pitchFamily="34" charset="-122"/>
+                <a:cs typeface="Arial" pitchFamily="34" charset="-120"/>
+              </a:rPr>
+              <a:t>customercare@gruntechnology.com</a:t>
+            </a:r>
+            <a:br>
+              <a:rPr lang="en-US" sz="950" b="1" dirty="0">
+                <a:solidFill>
+                  <a:srgbClr val="222222"/>
+                </a:solidFill>
+                <a:latin typeface="Arial" pitchFamily="34" charset="0"/>
+                <a:ea typeface="Arial" pitchFamily="34" charset="-122"/>
+                <a:cs typeface="Arial" pitchFamily="34" charset="-120"/>
+              </a:rPr>
+            </a:br>
+            <a:r>
+              <a:rPr lang="en-US" sz="950" b="1" dirty="0">
+                <a:solidFill>
+                  <a:srgbClr val="222222"/>
+                </a:solidFill>
+                <a:latin typeface="Arial" pitchFamily="34" charset="0"/>
+                <a:ea typeface="Arial" pitchFamily="34" charset="-122"/>
+                <a:cs typeface="Arial" pitchFamily="34" charset="-120"/>
+              </a:rPr>
+              <a:t>Terms: 50% Down Payment, 50% Upon Delivery</a:t>
+            </a:r>
+            <a:endParaRPr lang="en-US" sz="950" dirty="0"/>
+          </a:p>
+        </p:txBody>
+      </p:sp>
+      <p:sp>
+        <p:nvSpPr>
+          <p:cNvPr id="43" name="Notes">
+            <a:extLst>
+              <a:ext uri="{FF2B5EF4-FFF2-40B4-BE49-F238E27FC236}">
+                <a16:creationId xmlns:a16="http://schemas.microsoft.com/office/drawing/2014/main" id="{928770D8-664A-3B4B-96CA-2795194957B0}"/>
+              </a:ext>
+            </a:extLst>
+          </p:cNvPr>
+          <p:cNvSpPr txBox="1"/>
+          <p:nvPr/>
+        </p:nvSpPr>
+        <p:spPr>
+          <a:xfrm>
+            <a:off x="457200" y="8770851"/>
+            <a:ext cx="4156364" cy="149629"/>
+          </a:xfrm>
+          <a:prstGeom prst="rect">
+            <a:avLst/>
+          </a:prstGeom>
+          <a:noFill/>
+          <a:ln/>
+        </p:spPr>
+        <p:txBody>
+          <a:bodyPr wrap="square" lIns="0" tIns="0" rIns="0" bIns="0" rtlCol="0" anchor="t"/>
+          <a:lstStyle/>
+          <a:p>
+            <a:r>
+              <a:rPr lang="en-US" sz="950" i="1" dirty="0">
+                <a:solidFill>
+                  <a:srgbClr val="222222"/>
+                </a:solidFill>
+                <a:latin typeface="Arial" pitchFamily="34" charset="0"/>
+                <a:ea typeface="Arial" pitchFamily="34" charset="-122"/>
+                <a:cs typeface="Arial" pitchFamily="34" charset="-120"/>
+              </a:rPr>
+              <a:t>The name, date and time are considered a digital signature of approval.</a:t>
+            </a:r>
+            <a:endParaRPr lang="en-US" sz="950" i="1" dirty="0"/>
           </a:p>
         </p:txBody>
       </p:sp>
@@ -3337,4 +3325,319 @@
     </a:ext>
   </a:extLst>
 </a:theme>
+</file>
+
+<file path=ppt/theme/theme2.xml><?xml version="1.0" encoding="utf-8"?>
+<a:theme xmlns:a="http://schemas.openxmlformats.org/drawingml/2006/main" name="Office Theme">
+  <a:themeElements>
+    <a:clrScheme name="Office">
+      <a:dk1>
+        <a:sysClr val="windowText" lastClr="000000"/>
+      </a:dk1>
+      <a:lt1>
+        <a:sysClr val="window" lastClr="FFFFFF"/>
+      </a:lt1>
+      <a:dk2>
+        <a:srgbClr val="0E2841"/>
+      </a:dk2>
+      <a:lt2>
+        <a:srgbClr val="E8E8E8"/>
+      </a:lt2>
+      <a:accent1>
+        <a:srgbClr val="156082"/>
+      </a:accent1>
+      <a:accent2>
+        <a:srgbClr val="E97132"/>
+      </a:accent2>
+      <a:accent3>
+        <a:srgbClr val="196B24"/>
+      </a:accent3>
+      <a:accent4>
+        <a:srgbClr val="0F9ED5"/>
+      </a:accent4>
+      <a:accent5>
+        <a:srgbClr val="A02B93"/>
+      </a:accent5>
+      <a:accent6>
+        <a:srgbClr val="4EA72E"/>
+      </a:accent6>
+      <a:hlink>
+        <a:srgbClr val="467886"/>
+      </a:hlink>
+      <a:folHlink>
+        <a:srgbClr val="96607D"/>
+      </a:folHlink>
+    </a:clrScheme>
+    <a:fontScheme name="Office">
+      <a:majorFont>
+        <a:latin typeface="Aptos Display" panose="02110004020202020204"/>
+        <a:ea typeface=""/>
+        <a:cs typeface=""/>
+        <a:font script="Jpan" typeface="游ゴシック Light"/>
+        <a:font script="Hang" typeface="맑은 고딕"/>
+        <a:font script="Hans" typeface="等线 Light"/>
+        <a:font script="Hant" typeface="新細明體"/>
+        <a:font script="Arab" typeface="Times New Roman"/>
+        <a:font script="Hebr" typeface="Times New Roman"/>
+        <a:font script="Thai" typeface="Angsana New"/>
+        <a:font script="Ethi" typeface="Nyala"/>
+        <a:font script="Beng" typeface="Vrinda"/>
+        <a:font script="Gujr" typeface="Shruti"/>
+        <a:font script="Khmr" typeface="MoolBoran"/>
+        <a:font script="Knda" typeface="Tunga"/>
+        <a:font script="Guru" typeface="Raavi"/>
+        <a:font script="Cans" typeface="Euphemia"/>
+        <a:font script="Cher" typeface="Plantagenet Cherokee"/>
+        <a:font script="Yiii" typeface="Microsoft Yi Baiti"/>
+        <a:font script="Tibt" typeface="Microsoft Himalaya"/>
+        <a:font script="Thaa" typeface="MV Boli"/>
+        <a:font script="Deva" typeface="Mangal"/>
+        <a:font script="Telu" typeface="Gautami"/>
+        <a:font script="Taml" typeface="Latha"/>
+        <a:font script="Syrc" typeface="Estrangelo Edessa"/>
+        <a:font script="Orya" typeface="Kalinga"/>
+        <a:font script="Mlym" typeface="Kartika"/>
+        <a:font script="Laoo" typeface="DokChampa"/>
+        <a:font script="Sinh" typeface="Iskoola Pota"/>
+        <a:font script="Mong" typeface="Mongolian Baiti"/>
+        <a:font script="Viet" typeface="Times New Roman"/>
+        <a:font script="Uigh" typeface="Microsoft Uighur"/>
+        <a:font script="Geor" typeface="Sylfaen"/>
+        <a:font script="Armn" typeface="Arial"/>
+        <a:font script="Bugi" typeface="Leelawadee UI"/>
+        <a:font script="Bopo" typeface="Microsoft JhengHei"/>
+        <a:font script="Java" typeface="Javanese Text"/>
+        <a:font script="Lisu" typeface="Segoe UI"/>
+        <a:font script="Mymr" typeface="Myanmar Text"/>
+        <a:font script="Nkoo" typeface="Ebrima"/>
+        <a:font script="Olck" typeface="Nirmala UI"/>
+        <a:font script="Osma" typeface="Ebrima"/>
+        <a:font script="Phag" typeface="Phagspa"/>
+        <a:font script="Syrn" typeface="Estrangelo Edessa"/>
+        <a:font script="Syrj" typeface="Estrangelo Edessa"/>
+        <a:font script="Syre" typeface="Estrangelo Edessa"/>
+        <a:font script="Sora" typeface="Nirmala UI"/>
+        <a:font script="Tale" typeface="Microsoft Tai Le"/>
+        <a:font script="Talu" typeface="Microsoft New Tai Lue"/>
+        <a:font script="Tfng" typeface="Ebrima"/>
+      </a:majorFont>
+      <a:minorFont>
+        <a:latin typeface="Aptos" panose="02110004020202020204"/>
+        <a:ea typeface=""/>
+        <a:cs typeface=""/>
+        <a:font script="Jpan" typeface="游ゴシック"/>
+        <a:font script="Hang" typeface="맑은 고딕"/>
+        <a:font script="Hans" typeface="等线"/>
+        <a:font script="Hant" typeface="新細明體"/>
+        <a:font script="Arab" typeface="Arial"/>
+        <a:font script="Hebr" typeface="Arial"/>
+        <a:font script="Thai" typeface="Cordia New"/>
+        <a:font script="Ethi" typeface="Nyala"/>
+        <a:font script="Beng" typeface="Vrinda"/>
+        <a:font script="Gujr" typeface="Shruti"/>
+        <a:font script="Khmr" typeface="DaunPenh"/>
+        <a:font script="Knda" typeface="Tunga"/>
+        <a:font script="Guru" typeface="Raavi"/>
+        <a:font script="Cans" typeface="Euphemia"/>
+        <a:font script="Cher" typeface="Plantagenet Cherokee"/>
+        <a:font script="Yiii" typeface="Microsoft Yi Baiti"/>
+        <a:font script="Tibt" typeface="Microsoft Himalaya"/>
+        <a:font script="Thaa" typeface="MV Boli"/>
+        <a:font script="Deva" typeface="Mangal"/>
+        <a:font script="Telu" typeface="Gautami"/>
+        <a:font script="Taml" typeface="Latha"/>
+        <a:font script="Syrc" typeface="Estrangelo Edessa"/>
+        <a:font script="Orya" typeface="Kalinga"/>
+        <a:font script="Mlym" typeface="Kartika"/>
+        <a:font script="Laoo" typeface="DokChampa"/>
+        <a:font script="Sinh" typeface="Iskoola Pota"/>
+        <a:font script="Mong" typeface="Mongolian Baiti"/>
+        <a:font script="Viet" typeface="Arial"/>
+        <a:font script="Uigh" typeface="Microsoft Uighur"/>
+        <a:font script="Geor" typeface="Sylfaen"/>
+        <a:font script="Armn" typeface="Arial"/>
+        <a:font script="Bugi" typeface="Leelawadee UI"/>
+        <a:font script="Bopo" typeface="Microsoft JhengHei"/>
+        <a:font script="Java" typeface="Javanese Text"/>
+        <a:font script="Lisu" typeface="Segoe UI"/>
+        <a:font script="Mymr" typeface="Myanmar Text"/>
+        <a:font script="Nkoo" typeface="Ebrima"/>
+        <a:font script="Olck" typeface="Nirmala UI"/>
+        <a:font script="Osma" typeface="Ebrima"/>
+        <a:font script="Phag" typeface="Phagspa"/>
+        <a:font script="Syrn" typeface="Estrangelo Edessa"/>
+        <a:font script="Syrj" typeface="Estrangelo Edessa"/>
+        <a:font script="Syre" typeface="Estrangelo Edessa"/>
+        <a:font script="Sora" typeface="Nirmala UI"/>
+        <a:font script="Tale" typeface="Microsoft Tai Le"/>
+        <a:font script="Talu" typeface="Microsoft New Tai Lue"/>
+        <a:font script="Tfng" typeface="Ebrima"/>
+      </a:minorFont>
+    </a:fontScheme>
+    <a:fmtScheme name="Office">
+      <a:fillStyleLst>
+        <a:solidFill>
+          <a:schemeClr val="phClr"/>
+        </a:solidFill>
+        <a:gradFill rotWithShape="1">
+          <a:gsLst>
+            <a:gs pos="0">
+              <a:schemeClr val="phClr">
+                <a:lumMod val="110000"/>
+                <a:satMod val="105000"/>
+                <a:tint val="67000"/>
+              </a:schemeClr>
+            </a:gs>
+            <a:gs pos="50000">
+              <a:schemeClr val="phClr">
+                <a:lumMod val="105000"/>
+                <a:satMod val="103000"/>
+                <a:tint val="73000"/>
+              </a:schemeClr>
+            </a:gs>
+            <a:gs pos="100000">
+              <a:schemeClr val="phClr">
+                <a:lumMod val="105000"/>
+                <a:satMod val="109000"/>
+                <a:tint val="81000"/>
+              </a:schemeClr>
+            </a:gs>
+          </a:gsLst>
+          <a:lin ang="5400000" scaled="0"/>
+        </a:gradFill>
+        <a:gradFill rotWithShape="1">
+          <a:gsLst>
+            <a:gs pos="0">
+              <a:schemeClr val="phClr">
+                <a:satMod val="103000"/>
+                <a:lumMod val="102000"/>
+                <a:tint val="94000"/>
+              </a:schemeClr>
+            </a:gs>
+            <a:gs pos="50000">
+              <a:schemeClr val="phClr">
+                <a:satMod val="110000"/>
+                <a:lumMod val="100000"/>
+                <a:shade val="100000"/>
+              </a:schemeClr>
+            </a:gs>
+            <a:gs pos="100000">
+              <a:schemeClr val="phClr">
+                <a:lumMod val="99000"/>
+                <a:satMod val="120000"/>
+                <a:shade val="78000"/>
+              </a:schemeClr>
+            </a:gs>
+          </a:gsLst>
+          <a:lin ang="5400000" scaled="0"/>
+        </a:gradFill>
+      </a:fillStyleLst>
+      <a:lnStyleLst>
+        <a:ln w="12700" cap="flat" cmpd="sng" algn="ctr">
+          <a:solidFill>
+            <a:schemeClr val="phClr"/>
+          </a:solidFill>
+          <a:prstDash val="solid"/>
+          <a:miter lim="800000"/>
+        </a:ln>
+        <a:ln w="19050" cap="flat" cmpd="sng" algn="ctr">
+          <a:solidFill>
+            <a:schemeClr val="phClr"/>
+          </a:solidFill>
+          <a:prstDash val="solid"/>
+          <a:miter lim="800000"/>
+        </a:ln>
+        <a:ln w="25400" cap="flat" cmpd="sng" algn="ctr">
+          <a:solidFill>
+            <a:schemeClr val="phClr"/>
+          </a:solidFill>
+          <a:prstDash val="solid"/>
+          <a:miter lim="800000"/>
+        </a:ln>
+      </a:lnStyleLst>
+      <a:effectStyleLst>
+        <a:effectStyle>
+          <a:effectLst/>
+        </a:effectStyle>
+        <a:effectStyle>
+          <a:effectLst/>
+        </a:effectStyle>
+        <a:effectStyle>
+          <a:effectLst>
+            <a:outerShdw blurRad="57150" dist="19050" dir="5400000" algn="ctr" rotWithShape="0">
+              <a:srgbClr val="000000">
+                <a:alpha val="63000"/>
+              </a:srgbClr>
+            </a:outerShdw>
+          </a:effectLst>
+        </a:effectStyle>
+      </a:effectStyleLst>
+      <a:bgFillStyleLst>
+        <a:solidFill>
+          <a:schemeClr val="phClr"/>
+        </a:solidFill>
+        <a:solidFill>
+          <a:schemeClr val="phClr">
+            <a:tint val="95000"/>
+            <a:satMod val="170000"/>
+          </a:schemeClr>
+        </a:solidFill>
+        <a:gradFill rotWithShape="1">
+          <a:gsLst>
+            <a:gs pos="0">
+              <a:schemeClr val="phClr">
+                <a:tint val="93000"/>
+                <a:satMod val="150000"/>
+                <a:shade val="98000"/>
+                <a:lumMod val="102000"/>
+              </a:schemeClr>
+            </a:gs>
+            <a:gs pos="50000">
+              <a:schemeClr val="phClr">
+                <a:tint val="98000"/>
+                <a:satMod val="130000"/>
+                <a:shade val="90000"/>
+                <a:lumMod val="103000"/>
+              </a:schemeClr>
+            </a:gs>
+            <a:gs pos="100000">
+              <a:schemeClr val="phClr">
+                <a:shade val="63000"/>
+                <a:satMod val="120000"/>
+              </a:schemeClr>
+            </a:gs>
+          </a:gsLst>
+          <a:lin ang="5400000" scaled="0"/>
+        </a:gradFill>
+      </a:bgFillStyleLst>
+    </a:fmtScheme>
+  </a:themeElements>
+  <a:objectDefaults>
+    <a:lnDef>
+      <a:spPr/>
+      <a:bodyPr/>
+      <a:lstStyle/>
+      <a:style>
+        <a:lnRef idx="2">
+          <a:schemeClr val="accent1"/>
+        </a:lnRef>
+        <a:fillRef idx="0">
+          <a:schemeClr val="accent1"/>
+        </a:fillRef>
+        <a:effectRef idx="1">
+          <a:schemeClr val="accent1"/>
+        </a:effectRef>
+        <a:fontRef idx="minor">
+          <a:schemeClr val="tx1"/>
+        </a:fontRef>
+      </a:style>
+    </a:lnDef>
+  </a:objectDefaults>
+  <a:extraClrSchemeLst/>
+  <a:extLst>
+    <a:ext uri="{05A4C25C-085E-4340-85A3-A5531E510DB2}">
+      <thm15:themeFamily xmlns:thm15="http://schemas.microsoft.com/office/thememl/2012/main" name="Office Theme" id="{2E142A2C-CD16-42D6-873A-C26D2A0506FA}" vid="{1BDDFF52-6CD6-40A5-AB3C-68EB2F1E4D0A}"/>
+    </a:ext>
+  </a:extLst>
+</a:theme>
 </file>
</xml_diff>

<commit_message>
Purchase order paper: details in columns with terms, Ship to block with the buyer, tighter address blocks
Co-Authored-By: Claude Opus 5.5 <noreply@anthropic.com>
Claude-Session: https://claude.ai/code/session_017S7WKxPcaD1eFJsYc4Pw2Y
</commit_message>
<xml_diff>
--- a/docs/mockups/purchase-order-layout.pptx
+++ b/docs/mockups/purchase-order-layout.pptx
@@ -1073,13 +1073,53 @@
           <a:bodyPr wrap="square" lIns="0" tIns="0" rIns="0" bIns="0" rtlCol="0" anchor="t"/>
           <a:lstStyle/>
           <a:p>
+            <a:pPr>
+              <a:lnSpc>
+                <a:spcPct val="130000"/>
+              </a:lnSpc>
+            </a:pPr>
+            <a:r>
+              <a:rPr lang="en-US" sz="950" b="1" dirty="0">
+                <a:solidFill>
+                  <a:srgbClr val="222222"/>
+                </a:solidFill>
+                <a:latin typeface="Arial" pitchFamily="34" charset="0"/>
+                <a:ea typeface="Arial" pitchFamily="34" charset="-122"/>
+                <a:cs typeface="Arial" pitchFamily="34" charset="-120"/>
+              </a:rPr>
+              <a:t>Quotation reference: SQ-2026-0412</a:t>
+            </a:r>
+            <a:br>
+              <a:rPr lang="en-US" sz="950" b="1" dirty="0">
+                <a:solidFill>
+                  <a:srgbClr val="222222"/>
+                </a:solidFill>
+                <a:latin typeface="Arial" pitchFamily="34" charset="0"/>
+                <a:ea typeface="Arial" pitchFamily="34" charset="-122"/>
+                <a:cs typeface="Arial" pitchFamily="34" charset="-120"/>
+              </a:rPr>
+            </a:br>
+            <a:r>
+              <a:rPr lang="en-US" sz="950" b="1" dirty="0">
+                <a:solidFill>
+                  <a:srgbClr val="222222"/>
+                </a:solidFill>
+                <a:latin typeface="Arial" pitchFamily="34" charset="0"/>
+                <a:ea typeface="Arial" pitchFamily="34" charset="-122"/>
+                <a:cs typeface="Arial" pitchFamily="34" charset="-120"/>
+              </a:rPr>
+              <a:t>Delivery date: October 28, 2026</a:t>
+            </a:r>
+            <a:endParaRPr lang="en-US" sz="950" dirty="0"/>
+          </a:p>
+          <a:p>
             <a:pPr marL="0" indent="0">
               <a:lnSpc>
                 <a:spcPct val="130000"/>
               </a:lnSpc>
               <a:buNone/>
             </a:pPr>
-            <a:r>
+            <a:br>
               <a:rPr lang="en-US" sz="950" b="1" dirty="0">
                 <a:solidFill>
                   <a:srgbClr val="222222"/>
@@ -1088,8 +1128,7 @@
                 <a:ea typeface="Arial" pitchFamily="34" charset="-122"/>
                 <a:cs typeface="Arial" pitchFamily="34" charset="-120"/>
               </a:rPr>
-              <a:t>Quotation reference: SQ-2026-0412</a:t>
-            </a:r>
+            </a:br>
             <a:endParaRPr lang="en-US" sz="950" dirty="0"/>
           </a:p>
         </p:txBody>
@@ -1102,7 +1141,7 @@
         </p:nvSpPr>
         <p:spPr>
           <a:xfrm>
-            <a:off x="457200" y="2431935"/>
+            <a:off x="457200" y="2535567"/>
             <a:ext cx="2493818" cy="149629"/>
           </a:xfrm>
           <a:prstGeom prst="rect">
@@ -1141,7 +1180,7 @@
         </p:nvSpPr>
         <p:spPr>
           <a:xfrm>
-            <a:off x="457200" y="2655455"/>
+            <a:off x="457200" y="2759087"/>
             <a:ext cx="3158836" cy="882072"/>
           </a:xfrm>
           <a:prstGeom prst="rect">
@@ -1158,7 +1197,7 @@
               <a:buNone/>
             </a:pPr>
             <a:r>
-              <a:rPr lang="en-US" sz="950" b="1" dirty="0">
+              <a:rPr lang="en-US" sz="900" b="1" dirty="0">
                 <a:solidFill>
                   <a:srgbClr val="222222"/>
                 </a:solidFill>
@@ -1169,7 +1208,7 @@
               <a:t>GAS ION TECHNOLOGY INC.</a:t>
             </a:r>
             <a:br>
-              <a:rPr lang="en-US" sz="950" b="1" dirty="0">
+              <a:rPr lang="en-US" sz="900" b="1" dirty="0">
                 <a:solidFill>
                   <a:srgbClr val="222222"/>
                 </a:solidFill>
@@ -1179,7 +1218,7 @@
               </a:rPr>
             </a:br>
             <a:r>
-              <a:rPr lang="en-US" sz="950" b="1" dirty="0">
+              <a:rPr lang="en-US" sz="900" b="1" dirty="0">
                 <a:solidFill>
                   <a:srgbClr val="222222"/>
                 </a:solidFill>
@@ -1190,7 +1229,7 @@
               <a:t>#27 Rajah Soliman Street </a:t>
             </a:r>
             <a:br>
-              <a:rPr lang="en-US" sz="950" b="1" dirty="0">
+              <a:rPr lang="en-US" sz="900" b="1" dirty="0">
                 <a:solidFill>
                   <a:srgbClr val="222222"/>
                 </a:solidFill>
@@ -1200,7 +1239,7 @@
               </a:rPr>
             </a:br>
             <a:r>
-              <a:rPr lang="en-US" sz="950" b="1" dirty="0">
+              <a:rPr lang="en-US" sz="900" b="1" dirty="0">
                 <a:solidFill>
                   <a:srgbClr val="222222"/>
                 </a:solidFill>
@@ -1211,7 +1250,7 @@
               <a:t>Barangay Marikina Heights Marikina City</a:t>
             </a:r>
             <a:br>
-              <a:rPr lang="en-US" sz="950" b="1" dirty="0">
+              <a:rPr lang="en-US" sz="900" b="1" dirty="0">
                 <a:solidFill>
                   <a:srgbClr val="222222"/>
                 </a:solidFill>
@@ -1221,7 +1260,7 @@
               </a:rPr>
             </a:br>
             <a:r>
-              <a:rPr lang="en-US" sz="950" b="1" dirty="0">
+              <a:rPr lang="en-US" sz="900" b="1" dirty="0">
                 <a:solidFill>
                   <a:srgbClr val="222222"/>
                 </a:solidFill>
@@ -1231,11 +1270,11 @@
               </a:rPr>
               <a:t>0917 555 0101</a:t>
             </a:r>
-            <a:endParaRPr lang="en-US" sz="950" dirty="0"/>
+            <a:endParaRPr lang="en-US" sz="900" dirty="0"/>
           </a:p>
           <a:p>
             <a:r>
-              <a:rPr lang="en-US" sz="950" b="1" dirty="0">
+              <a:rPr lang="en-US" sz="900" b="1" dirty="0">
                 <a:solidFill>
                   <a:srgbClr val="222222"/>
                 </a:solidFill>
@@ -1246,7 +1285,7 @@
               <a:t>Rosa Lim, Sales Engineer</a:t>
             </a:r>
             <a:br>
-              <a:rPr lang="en-US" sz="950" b="1" dirty="0">
+              <a:rPr lang="en-US" sz="900" b="1" dirty="0">
                 <a:solidFill>
                   <a:srgbClr val="222222"/>
                 </a:solidFill>
@@ -1256,7 +1295,7 @@
               </a:rPr>
             </a:br>
             <a:r>
-              <a:rPr lang="en-US" sz="950" b="1" dirty="0" err="1">
+              <a:rPr lang="en-US" sz="900" b="1" dirty="0" err="1">
                 <a:solidFill>
                   <a:srgbClr val="222222"/>
                 </a:solidFill>
@@ -1266,7 +1305,7 @@
               </a:rPr>
               <a:t>rosa.lim@gasion.example</a:t>
             </a:r>
-            <a:endParaRPr lang="en-US" sz="950" dirty="0"/>
+            <a:endParaRPr lang="en-US" sz="900" dirty="0"/>
           </a:p>
         </p:txBody>
       </p:sp>
@@ -1278,7 +1317,7 @@
         </p:nvSpPr>
         <p:spPr>
           <a:xfrm>
-            <a:off x="3781044" y="2439508"/>
+            <a:off x="3781044" y="2543140"/>
             <a:ext cx="2493818" cy="149629"/>
           </a:xfrm>
           <a:prstGeom prst="rect">
@@ -1300,10 +1339,9 @@
                   <a:srgbClr val="5B2A8C"/>
                 </a:solidFill>
                 <a:latin typeface="Arial" pitchFamily="34" charset="0"/>
-                <a:ea typeface="Arial" pitchFamily="34" charset="-122"/>
-                <a:cs typeface="Arial" pitchFamily="34" charset="-120"/>
-              </a:rPr>
-              <a:t>DELIVERY AND TERMS</a:t>
+                <a:cs typeface="Arial" pitchFamily="34" charset="-120"/>
+              </a:rPr>
+              <a:t>SHIP TO</a:t>
             </a:r>
             <a:endParaRPr lang="en-US" sz="850" dirty="0"/>
           </a:p>
@@ -1317,7 +1355,7 @@
         </p:nvSpPr>
         <p:spPr>
           <a:xfrm>
-            <a:off x="457200" y="3777673"/>
+            <a:off x="457200" y="3881305"/>
             <a:ext cx="2493818" cy="149629"/>
           </a:xfrm>
           <a:prstGeom prst="rect">
@@ -1357,13 +1395,13 @@
           <p:nvPr>
             <p:extLst>
               <p:ext uri="{D42A27DB-BD31-4B8C-83A1-F6EECF244321}">
-                <p14:modId xmlns:p14="http://schemas.microsoft.com/office/powerpoint/2010/main" val="3545928576"/>
+                <p14:modId xmlns:p14="http://schemas.microsoft.com/office/powerpoint/2010/main" val="3288137986"/>
               </p:ext>
             </p:extLst>
           </p:nvPr>
         </p:nvGraphicFramePr>
         <p:xfrm>
-          <a:off x="457200" y="4076931"/>
+          <a:off x="457200" y="4180563"/>
           <a:ext cx="6647688" cy="768096"/>
         </p:xfrm>
         <a:graphic>
@@ -2136,7 +2174,7 @@
         </p:nvSpPr>
         <p:spPr>
           <a:xfrm>
-            <a:off x="4247804" y="5157585"/>
+            <a:off x="4247804" y="5261217"/>
             <a:ext cx="1246909" cy="149629"/>
           </a:xfrm>
           <a:prstGeom prst="rect">
@@ -2175,7 +2213,7 @@
         </p:nvSpPr>
         <p:spPr>
           <a:xfrm>
-            <a:off x="5735782" y="5157585"/>
+            <a:off x="5735782" y="5261217"/>
             <a:ext cx="1280160" cy="149629"/>
           </a:xfrm>
           <a:prstGeom prst="rect">
@@ -2214,7 +2252,7 @@
         </p:nvSpPr>
         <p:spPr>
           <a:xfrm>
-            <a:off x="4156364" y="5398655"/>
+            <a:off x="4156364" y="5502287"/>
             <a:ext cx="2951018" cy="0"/>
           </a:xfrm>
           <a:prstGeom prst="line">
@@ -2237,7 +2275,7 @@
         </p:nvSpPr>
         <p:spPr>
           <a:xfrm>
-            <a:off x="4247804" y="5465156"/>
+            <a:off x="4247804" y="5568788"/>
             <a:ext cx="1246909" cy="149629"/>
           </a:xfrm>
           <a:prstGeom prst="rect">
@@ -2276,7 +2314,7 @@
         </p:nvSpPr>
         <p:spPr>
           <a:xfrm>
-            <a:off x="5735782" y="5465156"/>
+            <a:off x="5735782" y="5568788"/>
             <a:ext cx="1280160" cy="149629"/>
           </a:xfrm>
           <a:prstGeom prst="rect">
@@ -2315,7 +2353,7 @@
         </p:nvSpPr>
         <p:spPr>
           <a:xfrm>
-            <a:off x="4156364" y="5706225"/>
+            <a:off x="4156364" y="5809857"/>
             <a:ext cx="2951018" cy="0"/>
           </a:xfrm>
           <a:prstGeom prst="line">
@@ -2338,7 +2376,7 @@
         </p:nvSpPr>
         <p:spPr>
           <a:xfrm>
-            <a:off x="4247804" y="5797665"/>
+            <a:off x="4247804" y="5901297"/>
             <a:ext cx="1246909" cy="182880"/>
           </a:xfrm>
           <a:prstGeom prst="rect">
@@ -2377,7 +2415,7 @@
         </p:nvSpPr>
         <p:spPr>
           <a:xfrm>
-            <a:off x="5569527" y="5797665"/>
+            <a:off x="5569527" y="5901297"/>
             <a:ext cx="1446415" cy="182880"/>
           </a:xfrm>
           <a:prstGeom prst="rect">
@@ -2416,7 +2454,7 @@
         </p:nvSpPr>
         <p:spPr>
           <a:xfrm>
-            <a:off x="4156364" y="6088611"/>
+            <a:off x="4156364" y="6125187"/>
             <a:ext cx="2951018" cy="0"/>
           </a:xfrm>
           <a:prstGeom prst="line">
@@ -2439,7 +2477,7 @@
         </p:nvSpPr>
         <p:spPr>
           <a:xfrm>
-            <a:off x="457200" y="6263178"/>
+            <a:off x="457200" y="6366810"/>
             <a:ext cx="2493818" cy="149629"/>
           </a:xfrm>
           <a:prstGeom prst="rect">
@@ -2478,7 +2516,7 @@
         </p:nvSpPr>
         <p:spPr>
           <a:xfrm>
-            <a:off x="457200" y="6537498"/>
+            <a:off x="457200" y="6641130"/>
             <a:ext cx="4156364" cy="149629"/>
           </a:xfrm>
           <a:prstGeom prst="rect">
@@ -2798,7 +2836,7 @@
         </p:nvSpPr>
         <p:spPr>
           <a:xfrm>
-            <a:off x="3782291" y="2102195"/>
+            <a:off x="3782291" y="2102197"/>
             <a:ext cx="3325091" cy="224445"/>
           </a:xfrm>
           <a:prstGeom prst="rect">
@@ -2811,11 +2849,10 @@
           <a:bodyPr wrap="square" lIns="0" tIns="0" rIns="0" bIns="0" rtlCol="0" anchor="t"/>
           <a:lstStyle/>
           <a:p>
-            <a:pPr marL="0" indent="0">
+            <a:pPr>
               <a:lnSpc>
                 <a:spcPct val="130000"/>
               </a:lnSpc>
-              <a:buNone/>
             </a:pPr>
             <a:r>
               <a:rPr lang="en-US" sz="950" b="1" dirty="0">
@@ -2826,7 +2863,7 @@
                 <a:ea typeface="Arial" pitchFamily="34" charset="-122"/>
                 <a:cs typeface="Arial" pitchFamily="34" charset="-120"/>
               </a:rPr>
-              <a:t>Delivery date: October 28, 2026</a:t>
+              <a:t>Terms: 50% Down Payment, 50% Upon Delivery</a:t>
             </a:r>
             <a:endParaRPr lang="en-US" sz="950" dirty="0"/>
           </a:p>
@@ -2846,7 +2883,7 @@
         </p:nvSpPr>
         <p:spPr>
           <a:xfrm>
-            <a:off x="3782291" y="2655455"/>
+            <a:off x="3782291" y="2759087"/>
             <a:ext cx="3158836" cy="882072"/>
           </a:xfrm>
           <a:prstGeom prst="rect">
@@ -2863,7 +2900,7 @@
               <a:buNone/>
             </a:pPr>
             <a:r>
-              <a:rPr lang="en-US" sz="950" b="1" dirty="0">
+              <a:rPr lang="en-US" sz="900" b="1" dirty="0">
                 <a:solidFill>
                   <a:srgbClr val="222222"/>
                 </a:solidFill>
@@ -2874,7 +2911,7 @@
               <a:t>GRUNTECHNOLOGY CORPORATION</a:t>
             </a:r>
             <a:br>
-              <a:rPr lang="en-US" sz="950" b="1" dirty="0">
+              <a:rPr lang="en-US" sz="900" b="1" dirty="0">
                 <a:solidFill>
                   <a:srgbClr val="222222"/>
                 </a:solidFill>
@@ -2884,7 +2921,7 @@
               </a:rPr>
             </a:br>
             <a:r>
-              <a:rPr lang="en-US" sz="950" b="1" dirty="0">
+              <a:rPr lang="en-US" sz="900" b="1" dirty="0">
                 <a:solidFill>
                   <a:srgbClr val="222222"/>
                 </a:solidFill>
@@ -2895,7 +2932,7 @@
               <a:t>#2 Rajah Soliman Street </a:t>
             </a:r>
             <a:br>
-              <a:rPr lang="en-US" sz="950" b="1" dirty="0">
+              <a:rPr lang="en-US" sz="900" b="1" dirty="0">
                 <a:solidFill>
                   <a:srgbClr val="222222"/>
                 </a:solidFill>
@@ -2905,7 +2942,7 @@
               </a:rPr>
             </a:br>
             <a:r>
-              <a:rPr lang="en-US" sz="950" b="1" dirty="0">
+              <a:rPr lang="en-US" sz="900" b="1" dirty="0">
                 <a:solidFill>
                   <a:srgbClr val="222222"/>
                 </a:solidFill>
@@ -2916,7 +2953,7 @@
               <a:t>Barangay Parang Marikina City</a:t>
             </a:r>
             <a:br>
-              <a:rPr lang="en-US" sz="950" b="1" dirty="0">
+              <a:rPr lang="en-US" sz="900" b="1" dirty="0">
                 <a:solidFill>
                   <a:srgbClr val="222222"/>
                 </a:solidFill>
@@ -2926,7 +2963,7 @@
               </a:rPr>
             </a:br>
             <a:r>
-              <a:rPr lang="en-US" sz="950" b="1" dirty="0">
+              <a:rPr lang="en-US" sz="900" b="1" dirty="0">
                 <a:solidFill>
                   <a:srgbClr val="222222"/>
                 </a:solidFill>
@@ -2937,7 +2974,7 @@
               <a:t>+63286554063</a:t>
             </a:r>
             <a:br>
-              <a:rPr lang="en-US" sz="950" b="1" dirty="0">
+              <a:rPr lang="en-US" sz="900" b="1" dirty="0">
                 <a:solidFill>
                   <a:srgbClr val="222222"/>
                 </a:solidFill>
@@ -2947,7 +2984,7 @@
               </a:rPr>
             </a:br>
             <a:r>
-              <a:rPr lang="en-US" sz="950" b="1" dirty="0">
+              <a:rPr lang="en-US" sz="900" b="1" dirty="0">
                 <a:solidFill>
                   <a:srgbClr val="222222"/>
                 </a:solidFill>
@@ -2958,7 +2995,7 @@
               <a:t>customercare@gruntechnology.com</a:t>
             </a:r>
             <a:br>
-              <a:rPr lang="en-US" sz="950" b="1" dirty="0">
+              <a:rPr lang="en-US" sz="900" b="1" dirty="0">
                 <a:solidFill>
                   <a:srgbClr val="222222"/>
                 </a:solidFill>
@@ -2968,7 +3005,7 @@
               </a:rPr>
             </a:br>
             <a:r>
-              <a:rPr lang="en-US" sz="950" b="1" dirty="0">
+              <a:rPr lang="en-US" sz="900" b="1" dirty="0" err="1">
                 <a:solidFill>
                   <a:srgbClr val="222222"/>
                 </a:solidFill>
@@ -2976,9 +3013,42 @@
                 <a:ea typeface="Arial" pitchFamily="34" charset="-122"/>
                 <a:cs typeface="Arial" pitchFamily="34" charset="-120"/>
               </a:rPr>
-              <a:t>Terms: 50% Down Payment, 50% Upon Delivery</a:t>
-            </a:r>
-            <a:endParaRPr lang="en-US" sz="950" dirty="0"/>
+              <a:t>Wenchie</a:t>
+            </a:r>
+            <a:r>
+              <a:rPr lang="en-US" sz="900" b="1" dirty="0">
+                <a:solidFill>
+                  <a:srgbClr val="222222"/>
+                </a:solidFill>
+                <a:latin typeface="Arial" pitchFamily="34" charset="0"/>
+                <a:ea typeface="Arial" pitchFamily="34" charset="-122"/>
+                <a:cs typeface="Arial" pitchFamily="34" charset="-120"/>
+              </a:rPr>
+              <a:t> </a:t>
+            </a:r>
+            <a:r>
+              <a:rPr lang="en-US" sz="900" b="1" dirty="0" err="1">
+                <a:solidFill>
+                  <a:srgbClr val="222222"/>
+                </a:solidFill>
+                <a:latin typeface="Arial" pitchFamily="34" charset="0"/>
+                <a:ea typeface="Arial" pitchFamily="34" charset="-122"/>
+                <a:cs typeface="Arial" pitchFamily="34" charset="-120"/>
+              </a:rPr>
+              <a:t>Marcellano</a:t>
+            </a:r>
+            <a:r>
+              <a:rPr lang="en-US" sz="900" b="1" dirty="0">
+                <a:solidFill>
+                  <a:srgbClr val="222222"/>
+                </a:solidFill>
+                <a:latin typeface="Arial" pitchFamily="34" charset="0"/>
+                <a:ea typeface="Arial" pitchFamily="34" charset="-122"/>
+                <a:cs typeface="Arial" pitchFamily="34" charset="-120"/>
+              </a:rPr>
+              <a:t>, Back Support</a:t>
+            </a:r>
+            <a:endParaRPr lang="en-US" sz="900" dirty="0"/>
           </a:p>
         </p:txBody>
       </p:sp>

</xml_diff>